<commit_message>
fix(slides): eradicate text bleeding and replace static methodology with accepted 6-phase engineering framework diagram
</commit_message>
<xml_diff>
--- a/write_up/Project Final Defense Slides_ENHANCED.pptx
+++ b/write_up/Project Final Defense Slides_ENHANCED.pptx
@@ -1744,8 +1744,8 @@
         </p:nvSpPr>
         <p:spPr>
           <a:xfrm>
-            <a:off x="5921829" y="1"/>
-            <a:ext cx="6270171" cy="6857999"/>
+            <a:off x="5897880" y="365760"/>
+            <a:ext cx="5852160" cy="6126480"/>
           </a:xfrm>
           <a:prstGeom prst="rect">
             <a:avLst/>
@@ -1771,59 +1771,95 @@
           </a:fontRef>
         </p:style>
         <p:txBody>
-          <a:bodyPr rtlCol="0" anchor="ctr"/>
+          <a:bodyPr rtlCol="0" anchor="ctr" wrap="square" tIns="91440" bIns="91440" lIns="182880" rIns="182880"/>
           <a:lstStyle/>
           <a:p>
             <a:pPr algn="ctr">
               <a:lnSpc>
                 <a:spcPct val="150000"/>
               </a:lnSpc>
-              <a:defRPr sz="1400" b="1"/>
+              <a:spcAft>
+                <a:spcPts val="100"/>
+              </a:spcAft>
+              <a:defRPr sz="1200" b="1" i="0"/>
             </a:pPr>
             <a:r>
               <a:t>FACULTY OF ENGINEERING</a:t>
             </a:r>
-            <a:br/>
+          </a:p>
+          <a:p>
+            <a:pPr>
+              <a:spcAft>
+                <a:spcPts val="1000"/>
+              </a:spcAft>
+              <a:defRPr sz="1200" b="1" i="0"/>
+            </a:pPr>
             <a:r>
               <a:t>DEPARTMENT OF COMPUTER ENGINEERING</a:t>
             </a:r>
           </a:p>
           <a:p>
-            <a:br/>
             <a:pPr>
-              <a:defRPr sz="1800" b="1"/>
+              <a:spcAft>
+                <a:spcPts val="1000"/>
+              </a:spcAft>
+              <a:defRPr sz="1400" b="1" i="0"/>
             </a:pPr>
             <a:r>
               <a:t>DEVELOPMENT AND IMPLEMENTATION OF A ROBOTIC APPLICATION FOR HUMAN INTENTION RECOGNITION USING MOTION AND HAND GESTURE</a:t>
             </a:r>
           </a:p>
           <a:p>
-            <a:br/>
             <a:pPr>
-              <a:defRPr sz="1200" i="1"/>
+              <a:spcAft>
+                <a:spcPts val="1400"/>
+              </a:spcAft>
+              <a:defRPr sz="1050" b="0" i="1"/>
             </a:pPr>
             <a:r>
               <a:t>A Final Project Report Submitted in Partial Fulfillment of the Requirements for the Degree of BSc. Computer Engineering</a:t>
             </a:r>
           </a:p>
           <a:p>
-            <a:br/>
             <a:pPr>
-              <a:defRPr sz="1200" b="1"/>
+              <a:spcAft>
+                <a:spcPts val="100"/>
+              </a:spcAft>
+              <a:defRPr sz="1100" b="1" i="0"/>
             </a:pPr>
             <a:r>
               <a:t>PRESENTED BY:</a:t>
             </a:r>
-            <a:br/>
+          </a:p>
+          <a:p>
+            <a:pPr>
+              <a:spcAft>
+                <a:spcPts val="100"/>
+              </a:spcAft>
+              <a:defRPr sz="1100" b="0" i="0"/>
+            </a:pPr>
             <a:r>
               <a:t>ELEANA OSEI OWUSU — 4121230024</a:t>
             </a:r>
-            <a:br/>
+          </a:p>
+          <a:p>
+            <a:pPr>
+              <a:spcAft>
+                <a:spcPts val="1000"/>
+              </a:spcAft>
+              <a:defRPr sz="1100" b="0" i="0"/>
+            </a:pPr>
             <a:r>
               <a:t>JOEL NII ADJETEY AHULU — 4121230020</a:t>
             </a:r>
-            <a:br/>
-            <a:br/>
+          </a:p>
+          <a:p>
+            <a:pPr>
+              <a:spcAft>
+                <a:spcPts val="0"/>
+              </a:spcAft>
+              <a:defRPr sz="1100" b="1" i="0"/>
+            </a:pPr>
             <a:r>
               <a:t>SUPERVISOR: MR. MICHEAL XENYA</a:t>
             </a:r>
@@ -2171,13 +2207,25 @@
           </a:bodyPr>
           <a:lstStyle/>
           <a:p>
+            <a:pPr>
+              <a:spcAft>
+                <a:spcPts val="100"/>
+              </a:spcAft>
+              <a:defRPr sz="950" b="1" i="0"/>
+            </a:pPr>
             <a:r>
               <a:t>Figure 5: Raspberry Pi 5 (8GB RAM)</a:t>
             </a:r>
           </a:p>
           <a:p>
-            <a:r>
-              <a:t>Main edge SBC processing YOLOv8, MediaPipe, 19-D MLP, and SLAM/Nav2 directly onboard at 28.4 FPS.</a:t>
+            <a:pPr>
+              <a:spcAft>
+                <a:spcPts val="0"/>
+              </a:spcAft>
+              <a:defRPr sz="850" b="0" i="0"/>
+            </a:pPr>
+            <a:r>
+              <a:t>Edge SBC running ROS 2 Humble, MediaPipe, 19-D MLP, and SLAM/Nav2 directly onboard at 28.4 FPS on CPU.</a:t>
             </a:r>
           </a:p>
         </p:txBody>
@@ -2204,11 +2252,23 @@
           </a:bodyPr>
           <a:lstStyle/>
           <a:p>
+            <a:pPr>
+              <a:spcAft>
+                <a:spcPts val="100"/>
+              </a:spcAft>
+              <a:defRPr sz="950" b="1" i="0"/>
+            </a:pPr>
             <a:r>
               <a:t>Figure 6: USB Monocular Camera</a:t>
             </a:r>
           </a:p>
           <a:p>
+            <a:pPr>
+              <a:spcAft>
+                <a:spcPts val="0"/>
+              </a:spcAft>
+              <a:defRPr sz="850" b="0" i="0"/>
+            </a:pPr>
             <a:r>
               <a:t>Captures 640x480 RGB frames at 30 FPS for gesture classification and active gimbal tracking.</a:t>
             </a:r>
@@ -2237,13 +2297,25 @@
           </a:bodyPr>
           <a:lstStyle/>
           <a:p>
+            <a:pPr>
+              <a:spcAft>
+                <a:spcPts val="100"/>
+              </a:spcAft>
+              <a:defRPr sz="950" b="1" i="0"/>
+            </a:pPr>
             <a:r>
               <a:t>Figure 7: MS200 2D Planar LiDAR</a:t>
             </a:r>
           </a:p>
           <a:p>
-            <a:r>
-              <a:t>Provides 360° laser scans at 10 Hz up to 12m for SLAM Toolbox and triggers the 0.36m ISO 15066 safety halt.</a:t>
+            <a:pPr>
+              <a:spcAft>
+                <a:spcPts val="0"/>
+              </a:spcAft>
+              <a:defRPr sz="850" b="0" i="0"/>
+            </a:pPr>
+            <a:r>
+              <a:t>Provides 360° laser scans at 10 Hz up to 12m for SLAM and triggers the 0.36m ISO 15066 safety halt.</a:t>
             </a:r>
           </a:p>
         </p:txBody>
@@ -2370,13 +2442,25 @@
           </a:bodyPr>
           <a:lstStyle/>
           <a:p>
+            <a:pPr>
+              <a:spcAft>
+                <a:spcPts val="100"/>
+              </a:spcAft>
+              <a:defRPr sz="950" b="1" i="0"/>
+            </a:pPr>
             <a:r>
               <a:t>Figure 8: Dual-Bus Power Regulation</a:t>
             </a:r>
           </a:p>
           <a:p>
-            <a:r>
-              <a:t>7.4V 2S Li-ion battery pack with decoupled DC regulation isolating Pi 5 5V logic from motor torque spikes.</a:t>
+            <a:pPr>
+              <a:spcAft>
+                <a:spcPts val="0"/>
+              </a:spcAft>
+              <a:defRPr sz="850" b="0" i="0"/>
+            </a:pPr>
+            <a:r>
+              <a:t>7.4V 2S Li-ion battery pack with decoupled DC regulation isolating Pi 5 logic from motor current spikes.</a:t>
             </a:r>
           </a:p>
         </p:txBody>
@@ -2403,11 +2487,23 @@
           </a:bodyPr>
           <a:lstStyle/>
           <a:p>
+            <a:pPr>
+              <a:spcAft>
+                <a:spcPts val="100"/>
+              </a:spcAft>
+              <a:defRPr sz="950" b="1" i="0"/>
+            </a:pPr>
             <a:r>
               <a:t>Figure 9: Yahboom 4WD Mobile Chassis</a:t>
             </a:r>
           </a:p>
           <a:p>
+            <a:pPr>
+              <a:spcAft>
+                <a:spcPts val="0"/>
+              </a:spcAft>
+              <a:defRPr sz="850" b="0" i="0"/>
+            </a:pPr>
             <a:r>
               <a:t>Differential-drive chassis with four geared DC motors and optical quadrature encoders.</a:t>
             </a:r>
@@ -2472,11 +2568,23 @@
           </a:bodyPr>
           <a:lstStyle/>
           <a:p>
+            <a:pPr>
+              <a:spcAft>
+                <a:spcPts val="100"/>
+              </a:spcAft>
+              <a:defRPr sz="950" b="1" i="0"/>
+            </a:pPr>
             <a:r>
               <a:t>Figure 10: ESP32-S3 Micro-ROS Co-Processor</a:t>
             </a:r>
           </a:p>
           <a:p>
+            <a:pPr>
+              <a:spcAft>
+                <a:spcPts val="0"/>
+              </a:spcAft>
+              <a:defRPr sz="850" b="0" i="0"/>
+            </a:pPr>
             <a:r>
               <a:t>Dedicated hard real-time co-processor regulating motor PWM and reading encoders over 921,600 baud UART.</a:t>
             </a:r>
@@ -3206,8 +3314,11 @@
           </a:bodyPr>
           <a:lstStyle/>
           <a:p>
-            <a:r>
-              <a:t>Figure 13: LSTM Path Predictor Training Loss &amp; Validation Convergence (ADE: 25.8 px, FDE: 32.4 px)</a:t>
+            <a:pPr>
+              <a:defRPr sz="950"/>
+            </a:pPr>
+            <a:r>
+              <a:t>Figure 13: LSTM Path Predictor Training Loss &amp; Convergence (ADE: 25.8 px, FDE: 32.4 px)</a:t>
             </a:r>
           </a:p>
         </p:txBody>
@@ -3626,6 +3737,9 @@
           </a:bodyPr>
           <a:lstStyle/>
           <a:p>
+            <a:pPr>
+              <a:defRPr sz="950"/>
+            </a:pPr>
             <a:r>
               <a:t>Figure 14: Initial SLAM Run — Hourglass Rotational Drift Defect (Unsynchronized IMU Yaw)</a:t>
             </a:r>
@@ -3720,6 +3834,9 @@
           </a:bodyPr>
           <a:lstStyle/>
           <a:p>
+            <a:pPr>
+              <a:defRPr sz="950"/>
+            </a:pPr>
             <a:r>
               <a:t>Figure 15: Final SLAM Run — Clean 5cm Metric Occupancy Grid Map (EKF Restamping Fix)</a:t>
             </a:r>
@@ -3867,6 +3984,9 @@
                     <a:bodyPr/>
                     <a:lstStyle/>
                     <a:p>
+                      <a:pPr>
+                        <a:defRPr sz="900"/>
+                      </a:pPr>
                       <a:r>
                         <a:rPr lang="en-GB" dirty="0"/>
                         <a:t>Gesture</a:t>
@@ -3880,6 +4000,9 @@
                     <a:bodyPr/>
                     <a:lstStyle/>
                     <a:p>
+                      <a:pPr>
+                        <a:defRPr sz="900"/>
+                      </a:pPr>
                       <a:r>
                         <a:rPr lang="en-GB" dirty="0"/>
                         <a:t>Total Trials </a:t>
@@ -3893,6 +4016,9 @@
                     <a:bodyPr/>
                     <a:lstStyle/>
                     <a:p>
+                      <a:pPr>
+                        <a:defRPr sz="900"/>
+                      </a:pPr>
                       <a:r>
                         <a:rPr lang="en-GB" sz="1600" dirty="0"/>
                         <a:t>Successful Trials </a:t>
@@ -3906,6 +4032,9 @@
                     <a:bodyPr/>
                     <a:lstStyle/>
                     <a:p>
+                      <a:pPr>
+                        <a:defRPr sz="900"/>
+                      </a:pPr>
                       <a:r>
                         <a:rPr lang="en-GB" dirty="0"/>
                         <a:t>Observed Accuracy (%)</a:t>
@@ -3926,6 +4055,9 @@
                     <a:bodyPr/>
                     <a:lstStyle/>
                     <a:p>
+                      <a:pPr>
+                        <a:defRPr sz="900"/>
+                      </a:pPr>
                       <a:r>
                         <a:rPr lang="en-GB" dirty="0"/>
                         <a:t>Stop</a:t>
@@ -3939,6 +4071,9 @@
                     <a:bodyPr/>
                     <a:lstStyle/>
                     <a:p>
+                      <a:pPr>
+                        <a:defRPr sz="900"/>
+                      </a:pPr>
                       <a:r>
                         <a:rPr lang="en-GB" dirty="0"/>
                         <a:t>30</a:t>
@@ -3952,6 +4087,9 @@
                     <a:bodyPr/>
                     <a:lstStyle/>
                     <a:p>
+                      <a:pPr>
+                        <a:defRPr sz="900"/>
+                      </a:pPr>
                       <a:r>
                         <a:rPr lang="en-GB" dirty="0"/>
                         <a:t>27</a:t>
@@ -3965,6 +4103,9 @@
                     <a:bodyPr/>
                     <a:lstStyle/>
                     <a:p>
+                      <a:pPr>
+                        <a:defRPr sz="900"/>
+                      </a:pPr>
                       <a:r>
                         <a:rPr lang="en-GB" dirty="0"/>
                         <a:t>90.0%</a:t>
@@ -3985,6 +4126,9 @@
                     <a:bodyPr/>
                     <a:lstStyle/>
                     <a:p>
+                      <a:pPr>
+                        <a:defRPr sz="900"/>
+                      </a:pPr>
                       <a:r>
                         <a:rPr lang="en-GB" dirty="0"/>
                         <a:t>Go</a:t>
@@ -3998,6 +4142,9 @@
                     <a:bodyPr/>
                     <a:lstStyle/>
                     <a:p>
+                      <a:pPr>
+                        <a:defRPr sz="900"/>
+                      </a:pPr>
                       <a:r>
                         <a:rPr lang="en-GB" dirty="0"/>
                         <a:t>30</a:t>
@@ -4011,6 +4158,9 @@
                     <a:bodyPr/>
                     <a:lstStyle/>
                     <a:p>
+                      <a:pPr>
+                        <a:defRPr sz="900"/>
+                      </a:pPr>
                       <a:r>
                         <a:rPr lang="en-GB" dirty="0"/>
                         <a:t>29</a:t>
@@ -4024,6 +4174,9 @@
                     <a:bodyPr/>
                     <a:lstStyle/>
                     <a:p>
+                      <a:pPr>
+                        <a:defRPr sz="900"/>
+                      </a:pPr>
                       <a:r>
                         <a:rPr lang="en-GB" dirty="0"/>
                         <a:t>96.7%</a:t>
@@ -4044,6 +4197,9 @@
                     <a:bodyPr/>
                     <a:lstStyle/>
                     <a:p>
+                      <a:pPr>
+                        <a:defRPr sz="900"/>
+                      </a:pPr>
                       <a:r>
                         <a:t>Follow</a:t>
                       </a:r>
@@ -4056,6 +4212,9 @@
                     <a:bodyPr/>
                     <a:lstStyle/>
                     <a:p>
+                      <a:pPr>
+                        <a:defRPr sz="900"/>
+                      </a:pPr>
                       <a:r>
                         <a:rPr lang="en-GB" dirty="0"/>
                         <a:t>30</a:t>
@@ -4069,6 +4228,9 @@
                     <a:bodyPr/>
                     <a:lstStyle/>
                     <a:p>
+                      <a:pPr>
+                        <a:defRPr sz="900"/>
+                      </a:pPr>
                       <a:r>
                         <a:rPr lang="en-GB" dirty="0"/>
                         <a:t>28</a:t>
@@ -4082,6 +4244,9 @@
                     <a:bodyPr/>
                     <a:lstStyle/>
                     <a:p>
+                      <a:pPr>
+                        <a:defRPr sz="900"/>
+                      </a:pPr>
                       <a:r>
                         <a:rPr lang="en-GB" dirty="0"/>
                         <a:t>93.3%</a:t>
@@ -4102,6 +4267,9 @@
                     <a:bodyPr/>
                     <a:lstStyle/>
                     <a:p>
+                      <a:pPr>
+                        <a:defRPr sz="900"/>
+                      </a:pPr>
                       <a:r>
                         <a:rPr lang="en-GB" dirty="0"/>
                         <a:t>Left</a:t>
@@ -4115,6 +4283,9 @@
                     <a:bodyPr/>
                     <a:lstStyle/>
                     <a:p>
+                      <a:pPr>
+                        <a:defRPr sz="900"/>
+                      </a:pPr>
                       <a:r>
                         <a:rPr lang="en-GB" dirty="0"/>
                         <a:t>30</a:t>
@@ -4128,6 +4299,9 @@
                     <a:bodyPr/>
                     <a:lstStyle/>
                     <a:p>
+                      <a:pPr>
+                        <a:defRPr sz="900"/>
+                      </a:pPr>
                       <a:r>
                         <a:rPr lang="en-GB" dirty="0"/>
                         <a:t>30</a:t>
@@ -4141,6 +4315,9 @@
                     <a:bodyPr/>
                     <a:lstStyle/>
                     <a:p>
+                      <a:pPr>
+                        <a:defRPr sz="900"/>
+                      </a:pPr>
                       <a:r>
                         <a:rPr lang="en-GB" dirty="0"/>
                         <a:t>100.0%</a:t>
@@ -4161,6 +4338,9 @@
                     <a:bodyPr/>
                     <a:lstStyle/>
                     <a:p>
+                      <a:pPr>
+                        <a:defRPr sz="900"/>
+                      </a:pPr>
                       <a:r>
                         <a:t>Right</a:t>
                       </a:r>
@@ -4173,6 +4353,9 @@
                     <a:bodyPr/>
                     <a:lstStyle/>
                     <a:p>
+                      <a:pPr>
+                        <a:defRPr sz="900"/>
+                      </a:pPr>
                       <a:r>
                         <a:rPr lang="en-GB" dirty="0"/>
                         <a:t>30</a:t>
@@ -4186,6 +4369,9 @@
                     <a:bodyPr/>
                     <a:lstStyle/>
                     <a:p>
+                      <a:pPr>
+                        <a:defRPr sz="900"/>
+                      </a:pPr>
                       <a:r>
                         <a:rPr lang="en-GB" dirty="0"/>
                         <a:t>30</a:t>
@@ -4199,6 +4385,9 @@
                     <a:bodyPr/>
                     <a:lstStyle/>
                     <a:p>
+                      <a:pPr>
+                        <a:defRPr sz="900"/>
+                      </a:pPr>
                       <a:r>
                         <a:rPr lang="en-GB" dirty="0"/>
                         <a:t>100.0%</a:t>
@@ -4219,6 +4408,9 @@
                     <a:bodyPr/>
                     <a:lstStyle/>
                     <a:p>
+                      <a:pPr>
+                        <a:defRPr sz="900"/>
+                      </a:pPr>
                       <a:r>
                         <a:rPr lang="en-GB" dirty="0"/>
                         <a:t>Back</a:t>
@@ -4232,6 +4424,9 @@
                     <a:bodyPr/>
                     <a:lstStyle/>
                     <a:p>
+                      <a:pPr>
+                        <a:defRPr sz="900"/>
+                      </a:pPr>
                       <a:r>
                         <a:rPr lang="en-GB" dirty="0"/>
                         <a:t>30</a:t>
@@ -4245,6 +4440,9 @@
                     <a:bodyPr/>
                     <a:lstStyle/>
                     <a:p>
+                      <a:pPr>
+                        <a:defRPr sz="900"/>
+                      </a:pPr>
                       <a:r>
                         <a:rPr lang="en-GB" dirty="0"/>
                         <a:t>30</a:t>
@@ -4258,6 +4456,9 @@
                     <a:bodyPr/>
                     <a:lstStyle/>
                     <a:p>
+                      <a:pPr>
+                        <a:defRPr sz="900"/>
+                      </a:pPr>
                       <a:r>
                         <a:rPr lang="en-GB" dirty="0"/>
                         <a:t>100.0%</a:t>
@@ -4278,6 +4479,9 @@
                     <a:bodyPr/>
                     <a:lstStyle/>
                     <a:p>
+                      <a:pPr>
+                        <a:defRPr sz="900"/>
+                      </a:pPr>
                       <a:r>
                         <a:rPr lang="en-GB" dirty="0"/>
                         <a:t>Aggregate</a:t>
@@ -4291,6 +4495,9 @@
                     <a:bodyPr/>
                     <a:lstStyle/>
                     <a:p>
+                      <a:pPr>
+                        <a:defRPr sz="900"/>
+                      </a:pPr>
                       <a:r>
                         <a:rPr lang="en-GB" dirty="0"/>
                         <a:t>180</a:t>
@@ -4304,6 +4511,9 @@
                     <a:bodyPr/>
                     <a:lstStyle/>
                     <a:p>
+                      <a:pPr>
+                        <a:defRPr sz="900"/>
+                      </a:pPr>
                       <a:r>
                         <a:rPr lang="en-GB" dirty="0"/>
                         <a:t>174</a:t>
@@ -4317,6 +4527,9 @@
                     <a:bodyPr/>
                     <a:lstStyle/>
                     <a:p>
+                      <a:pPr>
+                        <a:defRPr sz="900"/>
+                      </a:pPr>
                       <a:r>
                         <a:rPr lang="en-GB" dirty="0"/>
                         <a:t>96.67%</a:t>
@@ -4433,6 +4646,9 @@
           </a:bodyPr>
           <a:lstStyle/>
           <a:p>
+            <a:pPr>
+              <a:defRPr sz="950"/>
+            </a:pPr>
             <a:r>
               <a:t>Figure 16: Per-Class Classification Accuracy of the Trained MLP Gesture Model</a:t>
             </a:r>
@@ -5000,6 +5216,12 @@
           </a:bodyPr>
           <a:lstStyle/>
           <a:p>
+            <a:pPr>
+              <a:spcAft>
+                <a:spcPts val="200"/>
+              </a:spcAft>
+              <a:defRPr sz="950"/>
+            </a:pPr>
             <a:r>
               <a:rPr lang="en-GB" sz="2400" dirty="0">
                 <a:latin typeface="Gill Sans MT" panose="020B0502020104020203" pitchFamily="34" charset="0"/>
@@ -5014,6 +5236,12 @@
             </a:r>
           </a:p>
           <a:p>
+            <a:pPr>
+              <a:spcAft>
+                <a:spcPts val="200"/>
+              </a:spcAft>
+              <a:defRPr sz="950"/>
+            </a:pPr>
             <a:r>
               <a:rPr lang="en-GB" sz="2400" dirty="0">
                 <a:latin typeface="Gill Sans MT" panose="020B0502020104020203" pitchFamily="34" charset="0"/>
@@ -5028,6 +5256,12 @@
             </a:r>
           </a:p>
           <a:p>
+            <a:pPr>
+              <a:spcAft>
+                <a:spcPts val="200"/>
+              </a:spcAft>
+              <a:defRPr sz="950"/>
+            </a:pPr>
             <a:r>
               <a:rPr lang="en-GB" sz="2400" dirty="0">
                 <a:latin typeface="Gill Sans MT" panose="020B0502020104020203" pitchFamily="34" charset="0"/>
@@ -5042,6 +5276,12 @@
             </a:r>
           </a:p>
           <a:p>
+            <a:pPr>
+              <a:spcAft>
+                <a:spcPts val="200"/>
+              </a:spcAft>
+              <a:defRPr sz="950"/>
+            </a:pPr>
             <a:r>
               <a:rPr lang="en-GB" sz="2400" dirty="0">
                 <a:latin typeface="Gill Sans MT" panose="020B0502020104020203" pitchFamily="34" charset="0"/>
@@ -5056,6 +5296,12 @@
             </a:r>
           </a:p>
           <a:p>
+            <a:pPr>
+              <a:spcAft>
+                <a:spcPts val="200"/>
+              </a:spcAft>
+              <a:defRPr sz="950"/>
+            </a:pPr>
             <a:r>
               <a:rPr lang="en-GB" sz="2400" dirty="0">
                 <a:latin typeface="Gill Sans MT" panose="020B0502020104020203" pitchFamily="34" charset="0"/>
@@ -5064,6 +5310,12 @@
             </a:r>
           </a:p>
           <a:p>
+            <a:pPr>
+              <a:spcAft>
+                <a:spcPts val="200"/>
+              </a:spcAft>
+              <a:defRPr sz="950"/>
+            </a:pPr>
             <a:r>
               <a:rPr lang="en-GB" sz="2400" dirty="0">
                 <a:latin typeface="Gill Sans MT" panose="020B0502020104020203" pitchFamily="34" charset="0"/>
@@ -5072,6 +5324,12 @@
             </a:r>
           </a:p>
           <a:p>
+            <a:pPr>
+              <a:spcAft>
+                <a:spcPts val="200"/>
+              </a:spcAft>
+              <a:defRPr sz="950"/>
+            </a:pPr>
             <a:r>
               <a:rPr lang="en-GB" sz="2400" dirty="0">
                 <a:latin typeface="Gill Sans MT" panose="020B0502020104020203" pitchFamily="34" charset="0"/>
@@ -5167,8 +5425,12 @@
           <a:lstStyle/>
           <a:p>
             <a:pPr marL="285750" indent="-285750">
+              <a:spcAft>
+                <a:spcPts val="200"/>
+              </a:spcAft>
               <a:buFont typeface="Arial" panose="020B0604020202020204" pitchFamily="34" charset="0"/>
               <a:buChar char="•"/>
+              <a:defRPr sz="950"/>
             </a:pPr>
             <a:r>
               <a:rPr lang="en-GB" sz="2400" dirty="0">
@@ -5191,8 +5453,12 @@
           </a:p>
           <a:p>
             <a:pPr marL="285750" indent="-285750">
+              <a:spcAft>
+                <a:spcPts val="200"/>
+              </a:spcAft>
               <a:buFont typeface="Arial" panose="020B0604020202020204" pitchFamily="34" charset="0"/>
               <a:buChar char="•"/>
+              <a:defRPr sz="950"/>
             </a:pPr>
             <a:r>
               <a:rPr lang="en-GB" sz="2400" dirty="0">
@@ -5215,8 +5481,12 @@
           </a:p>
           <a:p>
             <a:pPr marL="285750" indent="-285750">
+              <a:spcAft>
+                <a:spcPts val="200"/>
+              </a:spcAft>
               <a:buFont typeface="Arial" panose="020B0604020202020204" pitchFamily="34" charset="0"/>
               <a:buChar char="•"/>
+              <a:defRPr sz="950"/>
             </a:pPr>
             <a:r>
               <a:rPr lang="en-GB" sz="2400" dirty="0">
@@ -5239,8 +5509,12 @@
           </a:p>
           <a:p>
             <a:pPr marL="285750" indent="-285750">
+              <a:spcAft>
+                <a:spcPts val="200"/>
+              </a:spcAft>
               <a:buFont typeface="Arial" panose="020B0604020202020204" pitchFamily="34" charset="0"/>
               <a:buChar char="•"/>
+              <a:defRPr sz="950"/>
             </a:pPr>
             <a:r>
               <a:rPr lang="en-GB" sz="2400" dirty="0">
@@ -5263,8 +5537,12 @@
           </a:p>
           <a:p>
             <a:pPr marL="285750" indent="-285750">
+              <a:spcAft>
+                <a:spcPts val="200"/>
+              </a:spcAft>
               <a:buFont typeface="Arial" panose="020B0604020202020204" pitchFamily="34" charset="0"/>
               <a:buChar char="•"/>
+              <a:defRPr sz="950"/>
             </a:pPr>
             <a:r>
               <a:rPr lang="en-GB" sz="2400" dirty="0">
@@ -5278,8 +5556,12 @@
           </a:p>
           <a:p>
             <a:pPr marL="285750" indent="-285750">
+              <a:spcAft>
+                <a:spcPts val="200"/>
+              </a:spcAft>
               <a:buFont typeface="Arial" panose="020B0604020202020204" pitchFamily="34" charset="0"/>
               <a:buChar char="•"/>
+              <a:defRPr sz="950"/>
             </a:pPr>
             <a:r>
               <a:rPr lang="en-GB" sz="2400" dirty="0">
@@ -5299,8 +5581,12 @@
           </a:p>
           <a:p>
             <a:pPr marL="285750" indent="-285750">
+              <a:spcAft>
+                <a:spcPts val="200"/>
+              </a:spcAft>
               <a:buFont typeface="Arial" panose="020B0604020202020204" pitchFamily="34" charset="0"/>
               <a:buChar char="•"/>
+              <a:defRPr sz="950"/>
             </a:pPr>
             <a:r>
               <a:rPr lang="en-GB" sz="2400" dirty="0">
@@ -5458,215 +5744,36 @@
               <a:lnSpc>
                 <a:spcPct val="150000"/>
               </a:lnSpc>
+              <a:spcAft>
+                <a:spcPts val="400"/>
+              </a:spcAft>
               <a:buNone/>
-            </a:pPr>
-            <a:r>
-              <a:rPr lang="en-US" sz="2000" b="1" dirty="0">
-                <a:latin typeface="Gill Sans MT" panose="020B0502020104020203" pitchFamily="34" charset="0"/>
-              </a:rPr>
-              <a:t>[1]</a:t>
-            </a:r>
-            <a:r>
-              <a:rPr lang="en-US" sz="2000" dirty="0">
-                <a:latin typeface="Gill Sans MT" panose="020B0502020104020203" pitchFamily="34" charset="0"/>
-              </a:rPr>
-              <a:t> D. </a:t>
-            </a:r>
-            <a:r>
-              <a:rPr lang="en-US" sz="2000" dirty="0" err="1">
-                <a:latin typeface="Gill Sans MT" panose="020B0502020104020203" pitchFamily="34" charset="0"/>
-              </a:rPr>
-              <a:t>Tsitos</a:t>
-            </a:r>
-            <a:r>
-              <a:rPr lang="en-US" sz="2000" dirty="0">
-                <a:latin typeface="Gill Sans MT" panose="020B0502020104020203" pitchFamily="34" charset="0"/>
-              </a:rPr>
-              <a:t> </a:t>
-            </a:r>
-            <a:r>
-              <a:rPr lang="en-US" sz="2000" i="1" dirty="0">
-                <a:latin typeface="Gill Sans MT" panose="020B0502020104020203" pitchFamily="34" charset="0"/>
-              </a:rPr>
-              <a:t>et al</a:t>
-            </a:r>
-            <a:r>
-              <a:rPr lang="en-US" sz="2000" dirty="0">
-                <a:latin typeface="Gill Sans MT" panose="020B0502020104020203" pitchFamily="34" charset="0"/>
-              </a:rPr>
-              <a:t>., “Real-Time Feasibility of a Human Intention Prediction Method Evaluated Through a Competitive Human–Robot Reaching Game,” </a:t>
-            </a:r>
-            <a:r>
-              <a:rPr lang="en-US" sz="2000" i="1" dirty="0">
-                <a:latin typeface="Gill Sans MT" panose="020B0502020104020203" pitchFamily="34" charset="0"/>
-              </a:rPr>
-              <a:t>IEEE Robotics and Automation Letters</a:t>
-            </a:r>
-            <a:r>
-              <a:rPr lang="en-US" sz="2000" dirty="0">
-                <a:latin typeface="Gill Sans MT" panose="020B0502020104020203" pitchFamily="34" charset="0"/>
-              </a:rPr>
-              <a:t>, vol. 7, no. 4, pp. 10034–10041, Oct. 2022. </a:t>
-            </a:r>
-          </a:p>
-          <a:p>
-            <a:pPr marL="0" indent="0">
-              <a:lnSpc>
-                <a:spcPct val="150000"/>
-              </a:lnSpc>
-              <a:buNone/>
-            </a:pPr>
-            <a:r>
-              <a:rPr lang="en-US" sz="2000" b="1" dirty="0">
-                <a:latin typeface="Gill Sans MT" panose="020B0502020104020203" pitchFamily="34" charset="0"/>
-              </a:rPr>
-              <a:t>[2]</a:t>
-            </a:r>
-            <a:r>
-              <a:rPr lang="en-US" sz="2000" dirty="0">
-                <a:latin typeface="Gill Sans MT" panose="020B0502020104020203" pitchFamily="34" charset="0"/>
-              </a:rPr>
-              <a:t> J. A. Mahmud, B. C. Das, J. Shin, K. M. </a:t>
-            </a:r>
-            <a:r>
-              <a:rPr lang="en-US" sz="2000" dirty="0" err="1">
-                <a:latin typeface="Gill Sans MT" panose="020B0502020104020203" pitchFamily="34" charset="0"/>
-              </a:rPr>
-              <a:t>Hasib</a:t>
-            </a:r>
-            <a:r>
-              <a:rPr lang="en-US" sz="2000" dirty="0">
-                <a:latin typeface="Gill Sans MT" panose="020B0502020104020203" pitchFamily="34" charset="0"/>
-              </a:rPr>
-              <a:t>, R. </a:t>
-            </a:r>
-            <a:r>
-              <a:rPr lang="en-US" sz="2000" dirty="0" err="1">
-                <a:latin typeface="Gill Sans MT" panose="020B0502020104020203" pitchFamily="34" charset="0"/>
-              </a:rPr>
-              <a:t>Sadik</a:t>
-            </a:r>
-            <a:r>
-              <a:rPr lang="en-US" sz="2000" dirty="0">
-                <a:latin typeface="Gill Sans MT" panose="020B0502020104020203" pitchFamily="34" charset="0"/>
-              </a:rPr>
-              <a:t>, and M. F. </a:t>
-            </a:r>
-            <a:r>
-              <a:rPr lang="en-US" sz="2000" dirty="0" err="1">
-                <a:latin typeface="Gill Sans MT" panose="020B0502020104020203" pitchFamily="34" charset="0"/>
-              </a:rPr>
-              <a:t>Mridha</a:t>
-            </a:r>
-            <a:r>
-              <a:rPr lang="en-US" sz="2000" dirty="0">
-                <a:latin typeface="Gill Sans MT" panose="020B0502020104020203" pitchFamily="34" charset="0"/>
-              </a:rPr>
-              <a:t>, “3D Gesture Recognition and Adaptation for Human–Robot Interaction,” </a:t>
-            </a:r>
-            <a:r>
-              <a:rPr lang="en-US" sz="2000" i="1" dirty="0">
-                <a:latin typeface="Gill Sans MT" panose="020B0502020104020203" pitchFamily="34" charset="0"/>
-              </a:rPr>
-              <a:t>IEEE Access</a:t>
-            </a:r>
-            <a:r>
-              <a:rPr lang="en-US" sz="2000" dirty="0">
-                <a:latin typeface="Gill Sans MT" panose="020B0502020104020203" pitchFamily="34" charset="0"/>
-              </a:rPr>
-              <a:t>, vol. 10, pp. 116485–116507, 2022.</a:t>
-            </a:r>
-          </a:p>
-          <a:p>
-            <a:pPr marL="0" indent="0">
-              <a:lnSpc>
-                <a:spcPct val="150000"/>
-              </a:lnSpc>
-              <a:buNone/>
-            </a:pPr>
-            <a:r>
-              <a:rPr lang="en-US" sz="2000" b="1" dirty="0">
-                <a:latin typeface="Gill Sans MT" panose="020B0502020104020203" pitchFamily="34" charset="0"/>
-              </a:rPr>
-              <a:t>[3]</a:t>
-            </a:r>
-            <a:r>
-              <a:rPr lang="en-US" sz="2000" dirty="0">
-                <a:latin typeface="Gill Sans MT" panose="020B0502020104020203" pitchFamily="34" charset="0"/>
-              </a:rPr>
-              <a:t> G. Yang, S. Wang, H. Okamura, Y. Ueda, T. </a:t>
-            </a:r>
-            <a:r>
-              <a:rPr lang="en-US" sz="2000" dirty="0" err="1">
-                <a:latin typeface="Gill Sans MT" panose="020B0502020104020203" pitchFamily="34" charset="0"/>
-              </a:rPr>
-              <a:t>Yasui</a:t>
-            </a:r>
-            <a:r>
-              <a:rPr lang="en-US" sz="2000" dirty="0">
-                <a:latin typeface="Gill Sans MT" panose="020B0502020104020203" pitchFamily="34" charset="0"/>
-              </a:rPr>
-              <a:t>, T. Yamada, Y. Miyazawa, S. Yoshida, Y. Inada, S. </a:t>
-            </a:r>
-            <a:r>
-              <a:rPr lang="en-US" sz="2000" dirty="0" err="1">
-                <a:latin typeface="Gill Sans MT" panose="020B0502020104020203" pitchFamily="34" charset="0"/>
-              </a:rPr>
-              <a:t>Ino</a:t>
-            </a:r>
-            <a:r>
-              <a:rPr lang="en-US" sz="2000" dirty="0">
-                <a:latin typeface="Gill Sans MT" panose="020B0502020104020203" pitchFamily="34" charset="0"/>
-              </a:rPr>
-              <a:t>, K. </a:t>
-            </a:r>
-            <a:r>
-              <a:rPr lang="en-US" sz="2000" dirty="0" err="1">
-                <a:latin typeface="Gill Sans MT" panose="020B0502020104020203" pitchFamily="34" charset="0"/>
-              </a:rPr>
-              <a:t>Okuhata</a:t>
-            </a:r>
-            <a:r>
-              <a:rPr lang="en-US" sz="2000" dirty="0">
-                <a:latin typeface="Gill Sans MT" panose="020B0502020104020203" pitchFamily="34" charset="0"/>
-              </a:rPr>
-              <a:t>, and Y. </a:t>
-            </a:r>
-            <a:r>
-              <a:rPr lang="en-US" sz="2000" dirty="0" err="1">
-                <a:latin typeface="Gill Sans MT" panose="020B0502020104020203" pitchFamily="34" charset="0"/>
-              </a:rPr>
-              <a:t>Mizobuchi</a:t>
-            </a:r>
-            <a:r>
-              <a:rPr lang="en-US" sz="2000" dirty="0">
-                <a:latin typeface="Gill Sans MT" panose="020B0502020104020203" pitchFamily="34" charset="0"/>
-              </a:rPr>
-              <a:t>, “Safe and Efficient Motion Planning for Material Transportation Robots Considering Intention Prediction of Obstacles,” in </a:t>
-            </a:r>
-            <a:r>
-              <a:rPr lang="en-US" sz="2000" i="1" dirty="0">
-                <a:latin typeface="Gill Sans MT" panose="020B0502020104020203" pitchFamily="34" charset="0"/>
-              </a:rPr>
-              <a:t>Proc. IEEE Int. Conf. Mechatronics </a:t>
-            </a:r>
-            <a:r>
-              <a:rPr lang="en-US" sz="2000" i="1" dirty="0" err="1">
-                <a:latin typeface="Gill Sans MT" panose="020B0502020104020203" pitchFamily="34" charset="0"/>
-              </a:rPr>
-              <a:t>Autom</a:t>
-            </a:r>
-            <a:r>
-              <a:rPr lang="en-US" sz="2000" i="1" dirty="0">
-                <a:latin typeface="Gill Sans MT" panose="020B0502020104020203" pitchFamily="34" charset="0"/>
-              </a:rPr>
-              <a:t>. (ICMA)</a:t>
-            </a:r>
-            <a:r>
-              <a:rPr lang="en-US" sz="2000" dirty="0">
-                <a:latin typeface="Gill Sans MT" panose="020B0502020104020203" pitchFamily="34" charset="0"/>
-              </a:rPr>
-              <a:t>, Harbin, China, Aug. 2023, pp. 1179–1184.</a:t>
+              <a:defRPr sz="900" b="0" i="0"/>
+            </a:pPr>
+            <a:r>
+              <a:t>[1] D. Tsitos et al., “Real-Time Feasibility of a Human Intention Prediction Method Evaluated Through a Competitive Human–Robot Reaching Game,” IEEE Robotics and Automation Letters, vol. 7, no. 4, pp. 10034–10041, Oct. 2022.</a:t>
+            </a:r>
+          </a:p>
+          <a:p>
+            <a:pPr>
+              <a:spcAft>
+                <a:spcPts val="400"/>
+              </a:spcAft>
+              <a:defRPr sz="900" b="0" i="0"/>
+            </a:pPr>
+            <a:r>
+              <a:t>[2] J. A. Mahmud, B. C. Das, J. Shin, K. M. Hasib, R. Sadik, and M. F. Mridha, “3D Gesture Recognition and Adaptation for Human–Robot Interaction,” IEEE Access, vol. 10, pp. 116485–116507, 2022.</a:t>
+            </a:r>
+          </a:p>
+          <a:p>
+            <a:pPr>
+              <a:spcAft>
+                <a:spcPts val="400"/>
+              </a:spcAft>
+              <a:defRPr sz="900" b="0" i="0"/>
+            </a:pPr>
+            <a:r>
+              <a:t>[3] G. Yang et al., “Safe and Efficient Motion Planning for Material Transportation Robots Considering Intention Prediction of Obstacles,” in Proc. IEEE Int. Conf. Mechatronics Autom. (ICMA), Harbin, China, 2023, pp. 1179–1184.</a:t>
             </a:r>
           </a:p>
         </p:txBody>
@@ -5738,8 +5845,11 @@
           <a:lstStyle/>
           <a:p>
             <a:pPr marL="0" indent="0" algn="ctr">
+              <a:spcAft>
+                <a:spcPts val="1000"/>
+              </a:spcAft>
               <a:buNone/>
-              <a:defRPr sz="3200" b="1"/>
+              <a:defRPr sz="2600" b="1" i="0"/>
             </a:pPr>
             <a:r>
               <a:t>Questions &amp; Discussion</a:t>
@@ -5755,9 +5865,11 @@
             </a:endParaRPr>
           </a:p>
           <a:p>
-            <a:br/>
-            <a:pPr>
-              <a:defRPr sz="1800" i="1">
+            <a:pPr algn="ctr">
+              <a:spcAft>
+                <a:spcPts val="200"/>
+              </a:spcAft>
+              <a:defRPr sz="1500" b="0" i="1">
                 <a:solidFill>
                   <a:srgbClr val="0096B4"/>
                 </a:solidFill>
@@ -5846,563 +5958,139 @@
           </a:p>
         </p:txBody>
       </p:sp>
-      <p:graphicFrame>
-        <p:nvGraphicFramePr>
-          <p:cNvPr id="4" name="Content Placeholder 3"/>
-          <p:cNvGraphicFramePr>
-            <a:graphicFrameLocks noGrp="1"/>
-          </p:cNvGraphicFramePr>
-          <p:nvPr>
-            <p:ph idx="1"/>
-            <p:extLst>
-              <p:ext uri="{D42A27DB-BD31-4B8C-83A1-F6EECF244321}">
-                <p14:modId xmlns:p14="http://schemas.microsoft.com/office/powerpoint/2010/main" val="2563616658"/>
-              </p:ext>
-            </p:extLst>
-          </p:nvPr>
-        </p:nvGraphicFramePr>
-        <p:xfrm>
-          <a:off x="717494" y="1267274"/>
-          <a:ext cx="10636306" cy="6590792"/>
-        </p:xfrm>
-        <a:graphic>
-          <a:graphicData uri="http://schemas.openxmlformats.org/drawingml/2006/table">
-            <a:tbl>
-              <a:tblPr firstRow="1" bandRow="1">
-                <a:tableStyleId>{5C22544A-7EE6-4342-B048-85BDC9FD1C3A}</a:tableStyleId>
-              </a:tblPr>
-              <a:tblGrid>
-                <a:gridCol w="5318153">
-                  <a:extLst>
-                    <a:ext uri="{9D8B030D-6E8A-4147-A177-3AD203B41FA5}">
-                      <a16:colId xmlns:a16="http://schemas.microsoft.com/office/drawing/2014/main" val="468815543"/>
-                    </a:ext>
-                  </a:extLst>
-                </a:gridCol>
-                <a:gridCol w="5318153">
-                  <a:extLst>
-                    <a:ext uri="{9D8B030D-6E8A-4147-A177-3AD203B41FA5}">
-                      <a16:colId xmlns:a16="http://schemas.microsoft.com/office/drawing/2014/main" val="2656849321"/>
-                    </a:ext>
-                  </a:extLst>
-                </a:gridCol>
-              </a:tblGrid>
-              <a:tr h="4122021">
-                <a:tc>
-                  <a:txBody>
-                    <a:bodyPr/>
-                    <a:lstStyle/>
-                    <a:p>
-                      <a:pPr marL="342900" indent="-342900">
-                        <a:lnSpc>
-                          <a:spcPct val="200000"/>
-                        </a:lnSpc>
-                        <a:buFont typeface="Wingdings" panose="05000000000000000000" pitchFamily="2" charset="2"/>
-                        <a:buChar char="§"/>
-                      </a:pPr>
-                      <a:r>
-                        <a:rPr lang="en-US" sz="2000" b="0" dirty="0">
-                          <a:solidFill>
-                            <a:schemeClr val="bg1"/>
-                          </a:solidFill>
-                          <a:latin typeface="Gill Sans MT" panose="020B0502020104020203" pitchFamily="34" charset="0"/>
-                        </a:rPr>
-                        <a:t>Introduction </a:t>
-                      </a:r>
-                    </a:p>
-                    <a:p>
-                      <a:pPr marL="342900" indent="-342900">
-                        <a:lnSpc>
-                          <a:spcPct val="200000"/>
-                        </a:lnSpc>
-                        <a:buFont typeface="Wingdings" panose="05000000000000000000" pitchFamily="2" charset="2"/>
-                        <a:buChar char="§"/>
-                      </a:pPr>
-                      <a:r>
-                        <a:rPr lang="en-US" sz="2000" b="0" dirty="0">
-                          <a:solidFill>
-                            <a:schemeClr val="bg1"/>
-                          </a:solidFill>
-                          <a:latin typeface="Gill Sans MT" panose="020B0502020104020203" pitchFamily="34" charset="0"/>
-                        </a:rPr>
-                        <a:t>Problem Statement </a:t>
-                      </a:r>
-                    </a:p>
-                    <a:p>
-                      <a:pPr marL="342900" indent="-342900">
-                        <a:lnSpc>
-                          <a:spcPct val="200000"/>
-                        </a:lnSpc>
-                        <a:buFont typeface="Wingdings" panose="05000000000000000000" pitchFamily="2" charset="2"/>
-                        <a:buChar char="§"/>
-                      </a:pPr>
-                      <a:r>
-                        <a:rPr lang="en-US" sz="2000" b="0" dirty="0">
-                          <a:solidFill>
-                            <a:schemeClr val="bg1"/>
-                          </a:solidFill>
-                          <a:latin typeface="Gill Sans MT" panose="020B0502020104020203" pitchFamily="34" charset="0"/>
-                        </a:rPr>
-                        <a:t>Objectives of Study </a:t>
-                      </a:r>
-                    </a:p>
-                    <a:p>
-                      <a:pPr marL="342900" indent="-342900">
-                        <a:lnSpc>
-                          <a:spcPct val="200000"/>
-                        </a:lnSpc>
-                        <a:buFont typeface="Wingdings" panose="05000000000000000000" pitchFamily="2" charset="2"/>
-                        <a:buChar char="§"/>
-                      </a:pPr>
-                      <a:r>
-                        <a:rPr lang="en-US" sz="2000" b="0" dirty="0">
-                          <a:solidFill>
-                            <a:schemeClr val="bg1"/>
-                          </a:solidFill>
-                          <a:latin typeface="Gill Sans MT" panose="020B0502020104020203" pitchFamily="34" charset="0"/>
-                        </a:rPr>
-                        <a:t>Significance of Study </a:t>
-                      </a:r>
-                    </a:p>
-                    <a:p>
-                      <a:pPr marL="342900" indent="-342900">
-                        <a:lnSpc>
-                          <a:spcPct val="200000"/>
-                        </a:lnSpc>
-                        <a:buFont typeface="Wingdings" panose="05000000000000000000" pitchFamily="2" charset="2"/>
-                        <a:buChar char="§"/>
-                      </a:pPr>
-                      <a:r>
-                        <a:rPr lang="en-US" sz="2000" b="0" dirty="0">
-                          <a:solidFill>
-                            <a:schemeClr val="bg1"/>
-                          </a:solidFill>
-                          <a:latin typeface="Gill Sans MT" panose="020B0502020104020203" pitchFamily="34" charset="0"/>
-                        </a:rPr>
-                        <a:t>Research</a:t>
-                      </a:r>
-                      <a:r>
-                        <a:rPr lang="en-US" sz="2000" b="0" baseline="0" dirty="0">
-                          <a:solidFill>
-                            <a:schemeClr val="bg1"/>
-                          </a:solidFill>
-                          <a:latin typeface="Gill Sans MT" panose="020B0502020104020203" pitchFamily="34" charset="0"/>
-                        </a:rPr>
-                        <a:t> Gaps</a:t>
-                      </a:r>
-                      <a:endParaRPr lang="en-US" sz="2000" b="0" dirty="0">
-                        <a:solidFill>
-                          <a:schemeClr val="bg1"/>
-                        </a:solidFill>
-                        <a:latin typeface="Gill Sans MT" panose="020B0502020104020203" pitchFamily="34" charset="0"/>
-                      </a:endParaRPr>
-                    </a:p>
-                    <a:p>
-                      <a:pPr marL="342900" marR="0" lvl="0" indent="-342900" algn="l" defTabSz="914400" rtl="0" eaLnBrk="1" fontAlgn="auto" latinLnBrk="0" hangingPunct="1">
-                        <a:lnSpc>
-                          <a:spcPct val="200000"/>
-                        </a:lnSpc>
-                        <a:spcBef>
-                          <a:spcPts val="0"/>
-                        </a:spcBef>
-                        <a:spcAft>
-                          <a:spcPts val="0"/>
-                        </a:spcAft>
-                        <a:buClrTx/>
-                        <a:buSzTx/>
-                        <a:buFont typeface="Wingdings" panose="05000000000000000000" pitchFamily="2" charset="2"/>
-                        <a:buChar char="§"/>
-                        <a:tabLst/>
-                        <a:defRPr/>
-                      </a:pPr>
-                      <a:r>
-                        <a:rPr lang="en-US" sz="2000" b="0" dirty="0">
-                          <a:solidFill>
-                            <a:schemeClr val="bg1"/>
-                          </a:solidFill>
-                          <a:latin typeface="Gill Sans MT" panose="020B0502020104020203" pitchFamily="34" charset="0"/>
-                        </a:rPr>
-                        <a:t>Literature</a:t>
-                      </a:r>
-                      <a:r>
-                        <a:rPr lang="en-US" sz="2000" b="0" baseline="0" dirty="0">
-                          <a:solidFill>
-                            <a:schemeClr val="bg1"/>
-                          </a:solidFill>
-                          <a:latin typeface="Gill Sans MT" panose="020B0502020104020203" pitchFamily="34" charset="0"/>
-                        </a:rPr>
-                        <a:t> Review</a:t>
-                      </a:r>
-                    </a:p>
-                    <a:p>
-                      <a:pPr marL="342900" marR="0" lvl="0" indent="-342900" algn="l" defTabSz="914400" rtl="0" eaLnBrk="1" fontAlgn="auto" latinLnBrk="0" hangingPunct="1">
-                        <a:lnSpc>
-                          <a:spcPct val="200000"/>
-                        </a:lnSpc>
-                        <a:spcBef>
-                          <a:spcPts val="0"/>
-                        </a:spcBef>
-                        <a:spcAft>
-                          <a:spcPts val="0"/>
-                        </a:spcAft>
-                        <a:buClrTx/>
-                        <a:buSzTx/>
-                        <a:buFont typeface="Wingdings" panose="05000000000000000000" pitchFamily="2" charset="2"/>
-                        <a:buChar char="§"/>
-                        <a:tabLst/>
-                        <a:defRPr/>
-                      </a:pPr>
-                      <a:r>
-                        <a:rPr lang="en-US" sz="2000" b="0" dirty="0">
-                          <a:solidFill>
-                            <a:schemeClr val="bg1"/>
-                          </a:solidFill>
-                          <a:latin typeface="Gill Sans MT" panose="020B0502020104020203" pitchFamily="34" charset="0"/>
-                        </a:rPr>
-                        <a:t>Methodology</a:t>
-                      </a:r>
-                    </a:p>
-                    <a:p>
-                      <a:pPr marL="342900" marR="0" lvl="0" indent="-342900" algn="l" defTabSz="914400" rtl="0" eaLnBrk="1" fontAlgn="auto" latinLnBrk="0" hangingPunct="1">
-                        <a:lnSpc>
-                          <a:spcPct val="200000"/>
-                        </a:lnSpc>
-                        <a:spcBef>
-                          <a:spcPts val="0"/>
-                        </a:spcBef>
-                        <a:spcAft>
-                          <a:spcPts val="0"/>
-                        </a:spcAft>
-                        <a:buClrTx/>
-                        <a:buSzTx/>
-                        <a:buFont typeface="Wingdings" panose="05000000000000000000" pitchFamily="2" charset="2"/>
-                        <a:buChar char="§"/>
-                        <a:tabLst/>
-                        <a:defRPr/>
-                      </a:pPr>
-                      <a:r>
-                        <a:rPr lang="en-US" sz="2000" b="0" dirty="0">
-                          <a:solidFill>
-                            <a:schemeClr val="bg1"/>
-                          </a:solidFill>
-                          <a:latin typeface="Gill Sans MT" panose="020B0502020104020203" pitchFamily="34" charset="0"/>
-                        </a:rPr>
-                        <a:t>System  Architecture</a:t>
-                      </a:r>
-                      <a:r>
-                        <a:rPr lang="en-US" sz="1600" b="1" dirty="0">
-                          <a:solidFill>
-                            <a:schemeClr val="bg1"/>
-                          </a:solidFill>
-                          <a:latin typeface="Gill Sans MT" panose="020B0502020104020203" pitchFamily="34" charset="0"/>
-                        </a:rPr>
-                        <a:t> </a:t>
-                      </a:r>
-                    </a:p>
-                    <a:p>
-                      <a:pPr marL="342900" marR="0" lvl="0" indent="-342900" algn="l" defTabSz="914400" rtl="0" eaLnBrk="1" fontAlgn="auto" latinLnBrk="0" hangingPunct="1">
-                        <a:lnSpc>
-                          <a:spcPct val="200000"/>
-                        </a:lnSpc>
-                        <a:spcBef>
-                          <a:spcPts val="0"/>
-                        </a:spcBef>
-                        <a:spcAft>
-                          <a:spcPts val="0"/>
-                        </a:spcAft>
-                        <a:buClrTx/>
-                        <a:buSzTx/>
-                        <a:buFont typeface="Wingdings" panose="05000000000000000000" pitchFamily="2" charset="2"/>
-                        <a:buChar char="§"/>
-                        <a:tabLst/>
-                        <a:defRPr/>
-                      </a:pPr>
-                      <a:endParaRPr lang="en-US" sz="1600" b="1" baseline="0" dirty="0">
-                        <a:solidFill>
-                          <a:schemeClr val="bg1"/>
-                        </a:solidFill>
-                        <a:latin typeface="Gill Sans MT" panose="020B0502020104020203" pitchFamily="34" charset="0"/>
-                      </a:endParaRPr>
-                    </a:p>
-                    <a:p>
-                      <a:pPr marL="342900" marR="0" lvl="0" indent="-342900" algn="l" defTabSz="914400" rtl="0" eaLnBrk="1" fontAlgn="auto" latinLnBrk="0" hangingPunct="1">
-                        <a:lnSpc>
-                          <a:spcPct val="200000"/>
-                        </a:lnSpc>
-                        <a:spcBef>
-                          <a:spcPts val="0"/>
-                        </a:spcBef>
-                        <a:spcAft>
-                          <a:spcPts val="0"/>
-                        </a:spcAft>
-                        <a:buClrTx/>
-                        <a:buSzTx/>
-                        <a:buFont typeface="Wingdings" panose="05000000000000000000" pitchFamily="2" charset="2"/>
-                        <a:buChar char="§"/>
-                        <a:tabLst/>
-                        <a:defRPr/>
-                      </a:pPr>
-                      <a:endParaRPr lang="en-US" sz="1600" b="1" dirty="0">
-                        <a:solidFill>
-                          <a:schemeClr val="bg1"/>
-                        </a:solidFill>
-                        <a:latin typeface="Gill Sans MT" panose="020B0502020104020203" pitchFamily="34" charset="0"/>
-                      </a:endParaRPr>
-                    </a:p>
-                    <a:p>
-                      <a:pPr marL="342900" indent="-342900">
-                        <a:lnSpc>
-                          <a:spcPct val="200000"/>
-                        </a:lnSpc>
-                        <a:buFont typeface="Wingdings" panose="05000000000000000000" pitchFamily="2" charset="2"/>
-                        <a:buChar char="§"/>
-                      </a:pPr>
-                      <a:endParaRPr lang="en-US" sz="2500" dirty="0">
-                        <a:solidFill>
-                          <a:schemeClr val="bg1"/>
-                        </a:solidFill>
-                        <a:latin typeface="Gill Sans MT" panose="020B0502020104020203" pitchFamily="34" charset="0"/>
-                      </a:endParaRPr>
-                    </a:p>
-                  </a:txBody>
-                  <a:tcPr>
-                    <a:lnL w="12700" cmpd="sng">
-                      <a:noFill/>
-                    </a:lnL>
-                    <a:lnR w="12700" cmpd="sng">
-                      <a:noFill/>
-                    </a:lnR>
-                    <a:lnT w="12700" cmpd="sng">
-                      <a:noFill/>
-                    </a:lnT>
-                    <a:lnB w="38100" cmpd="sng">
-                      <a:noFill/>
-                    </a:lnB>
-                    <a:lnTlToBr w="12700" cmpd="sng">
-                      <a:noFill/>
-                      <a:prstDash val="solid"/>
-                    </a:lnTlToBr>
-                    <a:lnBlToTr w="12700" cmpd="sng">
-                      <a:noFill/>
-                      <a:prstDash val="solid"/>
-                    </a:lnBlToTr>
-                    <a:noFill/>
-                  </a:tcPr>
-                </a:tc>
-                <a:tc>
-                  <a:txBody>
-                    <a:bodyPr/>
-                    <a:lstStyle/>
-                    <a:p>
-                      <a:pPr marL="342900" marR="0" lvl="0" indent="-342900" algn="l" defTabSz="914400" rtl="0" eaLnBrk="1" fontAlgn="auto" latinLnBrk="0" hangingPunct="1">
-                        <a:lnSpc>
-                          <a:spcPct val="200000"/>
-                        </a:lnSpc>
-                        <a:spcBef>
-                          <a:spcPts val="0"/>
-                        </a:spcBef>
-                        <a:spcAft>
-                          <a:spcPts val="0"/>
-                        </a:spcAft>
-                        <a:buClrTx/>
-                        <a:buSzTx/>
-                        <a:buFont typeface="Wingdings" panose="05000000000000000000" pitchFamily="2" charset="2"/>
-                        <a:buChar char="§"/>
-                        <a:tabLst/>
-                        <a:defRPr/>
-                      </a:pPr>
-                      <a:r>
-                        <a:rPr lang="en-US" sz="2000" b="0" dirty="0">
-                          <a:solidFill>
-                            <a:schemeClr val="bg1"/>
-                          </a:solidFill>
-                          <a:latin typeface="Gill Sans MT" panose="020B0502020104020203" pitchFamily="34" charset="0"/>
-                        </a:rPr>
-                        <a:t>Hardware</a:t>
-                      </a:r>
-                      <a:r>
-                        <a:rPr lang="en-US" sz="2000" b="0" baseline="0" dirty="0">
-                          <a:solidFill>
-                            <a:schemeClr val="bg1"/>
-                          </a:solidFill>
-                          <a:latin typeface="Gill Sans MT" panose="020B0502020104020203" pitchFamily="34" charset="0"/>
-                        </a:rPr>
-                        <a:t> and Software Components</a:t>
-                      </a:r>
-                      <a:endParaRPr lang="en-US" sz="2000" b="0" dirty="0">
-                        <a:solidFill>
-                          <a:schemeClr val="bg1"/>
-                        </a:solidFill>
-                        <a:latin typeface="Gill Sans MT" panose="020B0502020104020203" pitchFamily="34" charset="0"/>
-                      </a:endParaRPr>
-                    </a:p>
-                    <a:p>
-                      <a:pPr marL="342900" indent="-342900">
-                        <a:lnSpc>
-                          <a:spcPct val="200000"/>
-                        </a:lnSpc>
-                        <a:buFont typeface="Wingdings" panose="05000000000000000000" pitchFamily="2" charset="2"/>
-                        <a:buChar char="§"/>
-                      </a:pPr>
-                      <a:r>
-                        <a:rPr lang="en-US" sz="2000" b="0" dirty="0">
-                          <a:solidFill>
-                            <a:schemeClr val="bg1"/>
-                          </a:solidFill>
-                          <a:latin typeface="Gill Sans MT" panose="020B0502020104020203" pitchFamily="34" charset="0"/>
-                        </a:rPr>
-                        <a:t> Data</a:t>
-                      </a:r>
-                      <a:r>
-                        <a:rPr lang="en-US" sz="2000" b="0" baseline="0" dirty="0">
-                          <a:solidFill>
-                            <a:schemeClr val="bg1"/>
-                          </a:solidFill>
-                          <a:latin typeface="Gill Sans MT" panose="020B0502020104020203" pitchFamily="34" charset="0"/>
-                        </a:rPr>
-                        <a:t>set Preparation and Gesture Recognition</a:t>
-                      </a:r>
-                    </a:p>
-                    <a:p>
-                      <a:pPr marL="342900" indent="-342900">
-                        <a:lnSpc>
-                          <a:spcPct val="200000"/>
-                        </a:lnSpc>
-                        <a:buFont typeface="Wingdings" panose="05000000000000000000" pitchFamily="2" charset="2"/>
-                        <a:buChar char="§"/>
-                      </a:pPr>
-                      <a:r>
-                        <a:rPr lang="en-US" sz="2000" b="0" baseline="0" dirty="0">
-                          <a:solidFill>
-                            <a:schemeClr val="bg1"/>
-                          </a:solidFill>
-                          <a:latin typeface="Gill Sans MT" panose="020B0502020104020203" pitchFamily="34" charset="0"/>
-                        </a:rPr>
-                        <a:t>SLAM</a:t>
-                      </a:r>
-                    </a:p>
-                    <a:p>
-                      <a:pPr marL="342900" indent="-342900">
-                        <a:lnSpc>
-                          <a:spcPct val="200000"/>
-                        </a:lnSpc>
-                        <a:buFont typeface="Wingdings" panose="05000000000000000000" pitchFamily="2" charset="2"/>
-                        <a:buChar char="§"/>
-                      </a:pPr>
-                      <a:r>
-                        <a:rPr lang="en-US" sz="2000" b="0" dirty="0">
-                          <a:solidFill>
-                            <a:schemeClr val="bg1"/>
-                          </a:solidFill>
-                          <a:latin typeface="Gill Sans MT" panose="020B0502020104020203" pitchFamily="34" charset="0"/>
-                        </a:rPr>
-                        <a:t>Testing and Results</a:t>
-                      </a:r>
-                    </a:p>
-                    <a:p>
-                      <a:pPr marL="342900" indent="-342900">
-                        <a:lnSpc>
-                          <a:spcPct val="200000"/>
-                        </a:lnSpc>
-                        <a:buFont typeface="Wingdings" panose="05000000000000000000" pitchFamily="2" charset="2"/>
-                        <a:buChar char="§"/>
-                      </a:pPr>
-                      <a:r>
-                        <a:rPr lang="en-US" sz="2000" b="0" dirty="0">
-                          <a:solidFill>
-                            <a:schemeClr val="bg1"/>
-                          </a:solidFill>
-                          <a:latin typeface="Gill Sans MT" panose="020B0502020104020203" pitchFamily="34" charset="0"/>
-                        </a:rPr>
-                        <a:t> Conclusion</a:t>
-                      </a:r>
-                    </a:p>
-                    <a:p>
-                      <a:pPr marL="342900" indent="-342900">
-                        <a:lnSpc>
-                          <a:spcPct val="200000"/>
-                        </a:lnSpc>
-                        <a:buFont typeface="Wingdings" panose="05000000000000000000" pitchFamily="2" charset="2"/>
-                        <a:buChar char="§"/>
-                      </a:pPr>
-                      <a:r>
-                        <a:rPr lang="en-US" sz="2000" b="0" dirty="0">
-                          <a:solidFill>
-                            <a:schemeClr val="bg1"/>
-                          </a:solidFill>
-                          <a:latin typeface="Gill Sans MT" panose="020B0502020104020203" pitchFamily="34" charset="0"/>
-                        </a:rPr>
-                        <a:t>Future</a:t>
-                      </a:r>
-                      <a:r>
-                        <a:rPr lang="en-US" sz="2000" b="0" baseline="0" dirty="0">
-                          <a:solidFill>
-                            <a:schemeClr val="bg1"/>
-                          </a:solidFill>
-                          <a:latin typeface="Gill Sans MT" panose="020B0502020104020203" pitchFamily="34" charset="0"/>
-                        </a:rPr>
-                        <a:t> works</a:t>
-                      </a:r>
-                      <a:endParaRPr lang="en-US" sz="2000" b="0" dirty="0">
-                        <a:solidFill>
-                          <a:schemeClr val="bg1"/>
-                        </a:solidFill>
-                        <a:latin typeface="Gill Sans MT" panose="020B0502020104020203" pitchFamily="34" charset="0"/>
-                      </a:endParaRPr>
-                    </a:p>
-                    <a:p>
-                      <a:pPr marL="342900" indent="-342900">
-                        <a:lnSpc>
-                          <a:spcPct val="200000"/>
-                        </a:lnSpc>
-                        <a:buFont typeface="Wingdings" panose="05000000000000000000" pitchFamily="2" charset="2"/>
-                        <a:buChar char="§"/>
-                      </a:pPr>
-                      <a:r>
-                        <a:rPr lang="en-US" sz="2000" b="0" dirty="0">
-                          <a:solidFill>
-                            <a:schemeClr val="bg1"/>
-                          </a:solidFill>
-                          <a:latin typeface="Gill Sans MT" panose="020B0502020104020203" pitchFamily="34" charset="0"/>
-                        </a:rPr>
-                        <a:t>References</a:t>
-                      </a:r>
-                    </a:p>
-                  </a:txBody>
-                  <a:tcPr>
-                    <a:lnL w="12700" cmpd="sng">
-                      <a:noFill/>
-                    </a:lnL>
-                    <a:lnR w="12700" cmpd="sng">
-                      <a:noFill/>
-                    </a:lnR>
-                    <a:lnT w="12700" cmpd="sng">
-                      <a:noFill/>
-                    </a:lnT>
-                    <a:lnB w="38100" cmpd="sng">
-                      <a:noFill/>
-                    </a:lnB>
-                    <a:lnTlToBr w="12700" cmpd="sng">
-                      <a:noFill/>
-                      <a:prstDash val="solid"/>
-                    </a:lnTlToBr>
-                    <a:lnBlToTr w="12700" cmpd="sng">
-                      <a:noFill/>
-                      <a:prstDash val="solid"/>
-                    </a:lnBlToTr>
-                    <a:noFill/>
-                  </a:tcPr>
-                </a:tc>
-                <a:extLst>
-                  <a:ext uri="{0D108BD9-81ED-4DB2-BD59-A6C34878D82A}">
-                    <a16:rowId xmlns:a16="http://schemas.microsoft.com/office/drawing/2014/main" val="2124704652"/>
-                  </a:ext>
-                </a:extLst>
-              </a:tr>
-            </a:tbl>
-          </a:graphicData>
-        </a:graphic>
-      </p:graphicFrame>
+      <p:sp>
+        <p:nvSpPr>
+          <p:cNvPr id="3" name="TextBox 2"/>
+          <p:cNvSpPr txBox="1"/>
+          <p:nvPr/>
+        </p:nvSpPr>
+        <p:spPr>
+          <a:xfrm>
+            <a:off x="914400" y="1600200"/>
+            <a:ext cx="10360152" cy="4663440"/>
+          </a:xfrm>
+          <a:prstGeom prst="rect">
+            <a:avLst/>
+          </a:prstGeom>
+          <a:noFill/>
+        </p:spPr>
+        <p:txBody>
+          <a:bodyPr wrap="square">
+            <a:spAutoFit/>
+          </a:bodyPr>
+          <a:lstStyle/>
+          <a:p>
+            <a:pPr>
+              <a:spcAft>
+                <a:spcPts val="100"/>
+              </a:spcAft>
+              <a:defRPr sz="1200" b="1" i="0"/>
+            </a:pPr>
+            <a:r>
+              <a:t>01. INTRODUCTION &amp; PROBLEM CONTEXT</a:t>
+            </a:r>
+          </a:p>
+          <a:p>
+            <a:pPr>
+              <a:spcAft>
+                <a:spcPts val="500"/>
+              </a:spcAft>
+              <a:defRPr sz="1000" b="0" i="1"/>
+            </a:pPr>
+            <a:r>
+              <a:t>     • Motivation, Problem Statement, Objectives &amp; ERQs</a:t>
+            </a:r>
+          </a:p>
+          <a:p>
+            <a:pPr>
+              <a:spcAft>
+                <a:spcPts val="100"/>
+              </a:spcAft>
+              <a:defRPr sz="1200" b="1" i="0"/>
+            </a:pPr>
+            <a:r>
+              <a:t>02. LITERATURE REVIEW &amp; RESEARCH GAPS</a:t>
+            </a:r>
+          </a:p>
+          <a:p>
+            <a:pPr>
+              <a:spcAft>
+                <a:spcPts val="500"/>
+              </a:spcAft>
+              <a:defRPr sz="1000" b="0" i="1"/>
+            </a:pPr>
+            <a:r>
+              <a:t>     • Benchmark Studies (Tsitos, Mahmud, Li) &amp; The Central Gap</a:t>
+            </a:r>
+          </a:p>
+          <a:p>
+            <a:pPr>
+              <a:spcAft>
+                <a:spcPts val="100"/>
+              </a:spcAft>
+              <a:defRPr sz="1200" b="1" i="0"/>
+            </a:pPr>
+            <a:r>
+              <a:t>03. SYSTEM ARCHITECTURE &amp; METHODOLOGY</a:t>
+            </a:r>
+          </a:p>
+          <a:p>
+            <a:pPr>
+              <a:spcAft>
+                <a:spcPts val="500"/>
+              </a:spcAft>
+              <a:defRPr sz="1000" b="0" i="1"/>
+            </a:pPr>
+            <a:r>
+              <a:t>     • Mechatronic Hardware, 19-D Feature MLP, LSTM, Nav2/SLAM</a:t>
+            </a:r>
+          </a:p>
+          <a:p>
+            <a:pPr>
+              <a:spcAft>
+                <a:spcPts val="100"/>
+              </a:spcAft>
+              <a:defRPr sz="1200" b="1" i="0"/>
+            </a:pPr>
+            <a:r>
+              <a:t>04. EXPERIMENTAL VALIDATION &amp; RESULTS</a:t>
+            </a:r>
+          </a:p>
+          <a:p>
+            <a:pPr>
+              <a:spcAft>
+                <a:spcPts val="500"/>
+              </a:spcAft>
+              <a:defRPr sz="1000" b="0" i="1"/>
+            </a:pPr>
+            <a:r>
+              <a:t>     • Latency Budget (&lt;75 ms), Confusion Matrix &amp; Locomotion Trials</a:t>
+            </a:r>
+          </a:p>
+          <a:p>
+            <a:pPr>
+              <a:spcAft>
+                <a:spcPts val="100"/>
+              </a:spcAft>
+              <a:defRPr sz="1200" b="1" i="0"/>
+            </a:pPr>
+            <a:r>
+              <a:t>05. CONCLUSION &amp; RECOMMENDATIONS</a:t>
+            </a:r>
+          </a:p>
+          <a:p>
+            <a:pPr>
+              <a:spcAft>
+                <a:spcPts val="500"/>
+              </a:spcAft>
+              <a:defRPr sz="1000" b="0" i="1"/>
+            </a:pPr>
+            <a:r>
+              <a:t>     • Summary of Contributions, ISO 15066 Compliance &amp; Demonstration</a:t>
+            </a:r>
+          </a:p>
+        </p:txBody>
+      </p:sp>
     </p:spTree>
     <p:extLst>
       <p:ext uri="{BB962C8B-B14F-4D97-AF65-F5344CB8AC3E}">
@@ -7120,36 +6808,48 @@
           <a:lstStyle/>
           <a:p>
             <a:pPr>
+              <a:spcAft>
+                <a:spcPts val="500"/>
+              </a:spcAft>
               <a:buFont typeface="Wingdings" panose="05000000000000000000" pitchFamily="2" charset="2"/>
               <a:buChar char="§"/>
-              <a:defRPr sz="1300"/>
-            </a:pPr>
-            <a:r>
-              <a:t>• High-Power Compute &amp; Cloud Latency: Offboard cloud vision introduces unpredictable latency (&gt;200 ms) and connection dropouts, violating real-time robotic safety thresholds (Tsitos et al., 2022).</a:t>
+              <a:defRPr sz="1050" b="0" i="0"/>
+            </a:pPr>
+            <a:r>
+              <a:t>• High-Power Hardware &amp; Cloud Latency: Offboard cloud vision introduces unpredictable latency (&gt;200 ms) and connection drops, violating real-time robotic safety reaction limits (Tsitos et al., 2022).</a:t>
             </a:r>
           </a:p>
           <a:p>
             <a:pPr>
-              <a:defRPr sz="1300"/>
-            </a:pPr>
-            <a:r>
-              <a:t>• Spatial Domain Shift Across Distances: Models evaluating raw anatomical pixel coordinates suffer severe classification degradation as operator distance varies (1.0m to 2.5m) due to optical perspective scaling.</a:t>
+              <a:spcAft>
+                <a:spcPts val="500"/>
+              </a:spcAft>
+              <a:defRPr sz="1050" b="0" i="0"/>
+            </a:pPr>
+            <a:r>
+              <a:t>• Spatial Distance Domain Shift: Classifiers evaluating raw pixel coordinates degrade as operator distance varies (1.0m to 2.5m) due to optical perspective scaling.</a:t>
             </a:r>
           </a:p>
           <a:p>
             <a:pPr>
-              <a:defRPr sz="1300"/>
-            </a:pPr>
-            <a:r>
-              <a:t>• Ungrounded &amp; Spatial-Blind Execution: Executing recognized gestures blindly without continuous 360° laser mapping presents acute collision hazards in populated indoor workspaces.</a:t>
+              <a:spcAft>
+                <a:spcPts val="500"/>
+              </a:spcAft>
+              <a:defRPr sz="1050" b="0" i="0"/>
+            </a:pPr>
+            <a:r>
+              <a:t>• Ungrounded Spatial Command Execution: Executing recognized gestures blindly without continuous 360° laser mapping and obstacle verification presents severe collision hazards in shared indoor workspaces.</a:t>
             </a:r>
           </a:p>
           <a:p>
             <a:pPr>
-              <a:defRPr sz="1300"/>
-            </a:pPr>
-            <a:r>
-              <a:t>• Collaborative Safety Requirements: International standards (ISO 15066:2016) mandate speed and separation monitoring, requiring guaranteed deterministic halting distances (&lt;0.45m).</a:t>
+              <a:spcAft>
+                <a:spcPts val="500"/>
+              </a:spcAft>
+              <a:defRPr sz="1050" b="0" i="0"/>
+            </a:pPr>
+            <a:r>
+              <a:t>• Collaborative Safety Compliance: International standards (ISO 15066:2016) mandate speed and separation monitoring, requiring guaranteed deterministic halting distances (&lt;0.45m).</a:t>
             </a:r>
           </a:p>
         </p:txBody>
@@ -7247,7 +6947,7 @@
           </a:xfrm>
         </p:spPr>
         <p:txBody>
-          <a:bodyPr>
+          <a:bodyPr wrap="square">
             <a:noAutofit/>
           </a:bodyPr>
           <a:lstStyle/>
@@ -7256,8 +6956,11 @@
               <a:lnSpc>
                 <a:spcPct val="170000"/>
               </a:lnSpc>
+              <a:spcAft>
+                <a:spcPts val="100"/>
+              </a:spcAft>
               <a:buNone/>
-              <a:defRPr b="1" sz="1400"/>
+              <a:defRPr sz="1200" b="1" i="0"/>
             </a:pPr>
             <a:r>
               <a:t>General Objective:</a:t>
@@ -7265,16 +6968,21 @@
           </a:p>
           <a:p>
             <a:pPr>
-              <a:defRPr sz="1200"/>
+              <a:spcAft>
+                <a:spcPts val="500"/>
+              </a:spcAft>
+              <a:defRPr sz="1000" b="0" i="0"/>
             </a:pPr>
             <a:r>
               <a:t>To design, implement and evaluate an edge-based real-time human intention recognition system integrating hand gestures and autonomous navigation using ROS 2.</a:t>
             </a:r>
-            <a:br/>
           </a:p>
           <a:p>
             <a:pPr>
-              <a:defRPr b="1" sz="1400"/>
+              <a:spcAft>
+                <a:spcPts val="100"/>
+              </a:spcAft>
+              <a:defRPr sz="1200" b="1" i="0"/>
             </a:pPr>
             <a:r>
               <a:t>Specific Objectives:</a:t>
@@ -7282,7 +6990,10 @@
           </a:p>
           <a:p>
             <a:pPr>
-              <a:defRPr sz="1100"/>
+              <a:spcAft>
+                <a:spcPts val="200"/>
+              </a:spcAft>
+              <a:defRPr sz="950" b="0" i="0"/>
             </a:pPr>
             <a:r>
               <a:t>• To design and implement an edge-optimized vision pipeline using 19 scale-invariant geometric hand features.</a:t>
@@ -7290,23 +7001,32 @@
           </a:p>
           <a:p>
             <a:pPr>
-              <a:defRPr sz="1100"/>
-            </a:pPr>
-            <a:r>
-              <a:t>• To construct and balance a custom 6,000-sample gesture dataset captured directly through the robot camera.</a:t>
+              <a:spcAft>
+                <a:spcPts val="200"/>
+              </a:spcAft>
+              <a:defRPr sz="950" b="0" i="0"/>
+            </a:pPr>
+            <a:r>
+              <a:t>• To construct and balance a custom 6,000-sample gesture dataset captured directly through the onboard camera.</a:t>
             </a:r>
           </a:p>
           <a:p>
             <a:pPr>
-              <a:defRPr sz="1100"/>
-            </a:pPr>
-            <a:r>
-              <a:t>• To develop an LSTM recurrent model for short-horizon human trajectory prediction.</a:t>
+              <a:spcAft>
+                <a:spcPts val="200"/>
+              </a:spcAft>
+              <a:defRPr sz="950" b="0" i="0"/>
+            </a:pPr>
+            <a:r>
+              <a:t>• To develop an LSTM sequential recurrent model for short-horizon human trajectory prediction.</a:t>
             </a:r>
           </a:p>
           <a:p>
             <a:pPr>
-              <a:defRPr sz="1100"/>
+              <a:spcAft>
+                <a:spcPts val="200"/>
+              </a:spcAft>
+              <a:defRPr sz="950" b="0" i="0"/>
             </a:pPr>
             <a:r>
               <a:t>• To implement a deterministic supervisory decision node (brain_node) with rolling consensus and visual servoing.</a:t>
@@ -7314,7 +7034,10 @@
           </a:p>
           <a:p>
             <a:pPr>
-              <a:defRPr sz="1100"/>
+              <a:spcAft>
+                <a:spcPts val="200"/>
+              </a:spcAft>
+              <a:defRPr sz="950" b="0" i="0"/>
             </a:pPr>
             <a:r>
               <a:t>• To configure and validate LiDAR SLAM and Nav2 autonomous navigation for collision-free trajectory execution.</a:t>
@@ -7322,129 +7045,13 @@
           </a:p>
           <a:p>
             <a:pPr>
-              <a:defRPr sz="1100"/>
+              <a:spcAft>
+                <a:spcPts val="200"/>
+              </a:spcAft>
+              <a:defRPr sz="950" b="0" i="0"/>
             </a:pPr>
             <a:r>
               <a:t>• To quantitatively evaluate latency budgets (&lt;150 ms), classification accuracy, and real-time physical throughput.</a:t>
-            </a:r>
-          </a:p>
-        </p:txBody>
-      </p:sp>
-      <p:sp>
-        <p:nvSpPr>
-          <p:cNvPr id="11" name="Rectangle 8"/>
-          <p:cNvSpPr>
-            <a:spLocks noChangeArrowheads="1"/>
-          </p:cNvSpPr>
-          <p:nvPr/>
-        </p:nvSpPr>
-        <p:spPr bwMode="auto">
-          <a:xfrm>
-            <a:off x="0" y="-323165"/>
-            <a:ext cx="393056" cy="646331"/>
-          </a:xfrm>
-          <a:prstGeom prst="rect">
-            <a:avLst/>
-          </a:prstGeom>
-          <a:noFill/>
-          <a:ln>
-            <a:noFill/>
-          </a:ln>
-          <a:effectLst/>
-          <a:extLst>
-            <a:ext uri="{909E8E84-426E-40DD-AFC4-6F175D3DCCD1}">
-              <a14:hiddenFill xmlns:a14="http://schemas.microsoft.com/office/drawing/2010/main">
-                <a:solidFill>
-                  <a:schemeClr val="accent1"/>
-                </a:solidFill>
-              </a14:hiddenFill>
-            </a:ext>
-            <a:ext uri="{91240B29-F687-4F45-9708-019B960494DF}">
-              <a14:hiddenLine xmlns:a14="http://schemas.microsoft.com/office/drawing/2010/main" w="9525">
-                <a:solidFill>
-                  <a:schemeClr val="tx1"/>
-                </a:solidFill>
-                <a:miter lim="800000"/>
-                <a:headEnd/>
-                <a:tailEnd/>
-              </a14:hiddenLine>
-            </a:ext>
-            <a:ext uri="{AF507438-7753-43E0-B8FC-AC1667EBCBE1}">
-              <a14:hiddenEffects xmlns:a14="http://schemas.microsoft.com/office/drawing/2010/main">
-                <a:effectLst>
-                  <a:outerShdw dist="35921" dir="2700000" algn="ctr" rotWithShape="0">
-                    <a:schemeClr val="bg2"/>
-                  </a:outerShdw>
-                </a:effectLst>
-              </a14:hiddenEffects>
-            </a:ext>
-          </a:extLst>
-        </p:spPr>
-        <p:txBody>
-          <a:bodyPr vert="horz" wrap="none" lIns="91440" tIns="45720" rIns="91440" bIns="45720" numCol="1" anchor="ctr" anchorCtr="0" compatLnSpc="1">
-            <a:prstTxWarp prst="textNoShape">
-              <a:avLst/>
-            </a:prstTxWarp>
-            <a:spAutoFit/>
-          </a:bodyPr>
-          <a:lstStyle/>
-          <a:p>
-            <a:pPr marL="0" marR="0" lvl="0" indent="0" algn="l" defTabSz="914400" rtl="0" eaLnBrk="0" fontAlgn="base" latinLnBrk="0" hangingPunct="0">
-              <a:lnSpc>
-                <a:spcPct val="100000"/>
-              </a:lnSpc>
-              <a:spcBef>
-                <a:spcPct val="0"/>
-              </a:spcBef>
-              <a:spcAft>
-                <a:spcPct val="0"/>
-              </a:spcAft>
-              <a:buClrTx/>
-              <a:buSzTx/>
-              <a:buFontTx/>
-              <a:buNone/>
-              <a:tabLst/>
-            </a:pPr>
-            <a:endParaRPr kumimoji="0" lang="en-US" altLang="en-US" sz="1800" b="0" i="0" u="none" strike="noStrike" cap="none" normalizeH="0" baseline="0" dirty="0">
-              <a:ln>
-                <a:noFill/>
-              </a:ln>
-              <a:solidFill>
-                <a:schemeClr val="tx1"/>
-              </a:solidFill>
-              <a:effectLst/>
-              <a:latin typeface="Arial" panose="020B0604020202020204" pitchFamily="34" charset="0"/>
-            </a:endParaRPr>
-          </a:p>
-          <a:p>
-            <a:pPr marL="0" marR="0" lvl="0" indent="0" algn="l" defTabSz="914400" rtl="0" eaLnBrk="0" fontAlgn="base" latinLnBrk="0" hangingPunct="0">
-              <a:lnSpc>
-                <a:spcPct val="100000"/>
-              </a:lnSpc>
-              <a:spcBef>
-                <a:spcPct val="0"/>
-              </a:spcBef>
-              <a:spcAft>
-                <a:spcPct val="0"/>
-              </a:spcAft>
-              <a:buClrTx/>
-              <a:buSzTx/>
-              <a:buFontTx/>
-              <a:buChar char="•"/>
-              <a:tabLst/>
-            </a:pPr>
-            <a:r>
-              <a:rPr kumimoji="0" lang="en-US" altLang="en-US" sz="1800" b="0" i="0" u="none" strike="noStrike" cap="none" normalizeH="0" baseline="0" dirty="0">
-                <a:ln>
-                  <a:noFill/>
-                </a:ln>
-                <a:solidFill>
-                  <a:schemeClr val="tx1"/>
-                </a:solidFill>
-                <a:effectLst/>
-                <a:latin typeface="Arial" panose="020B0604020202020204" pitchFamily="34" charset="0"/>
-              </a:rPr>
-              <a:t>. </a:t>
             </a:r>
           </a:p>
         </p:txBody>
@@ -8317,7 +7924,9 @@
                     <a:bodyPr/>
                     <a:lstStyle/>
                     <a:p>
-                      <a:pPr algn="l"/>
+                      <a:pPr algn="l">
+                        <a:defRPr sz="800"/>
+                      </a:pPr>
                       <a:r>
                         <a:rPr lang="en-US" sz="1600" b="0" dirty="0">
                           <a:solidFill>
@@ -8334,14 +7943,16 @@
                       </a:r>
                     </a:p>
                   </a:txBody>
-                  <a:tcPr marL="121920" marR="121920" marT="76200" marB="76200" anchor="ctr"/>
+                  <a:tcPr marL="45720" marR="45720" marT="27432" marB="27432" anchor="ctr"/>
                 </a:tc>
                 <a:tc>
                   <a:txBody>
                     <a:bodyPr/>
                     <a:lstStyle/>
                     <a:p>
-                      <a:pPr algn="l"/>
+                      <a:pPr algn="l">
+                        <a:defRPr sz="800"/>
+                      </a:pPr>
                       <a:r>
                         <a:rPr lang="en-US" sz="1600" b="0">
                           <a:solidFill>
@@ -8358,14 +7969,16 @@
                       </a:r>
                     </a:p>
                   </a:txBody>
-                  <a:tcPr marL="121920" marR="121920" marT="76200" marB="76200" anchor="ctr"/>
+                  <a:tcPr marL="45720" marR="45720" marT="27432" marB="27432" anchor="ctr"/>
                 </a:tc>
                 <a:tc>
                   <a:txBody>
                     <a:bodyPr/>
                     <a:lstStyle/>
                     <a:p>
-                      <a:pPr algn="l"/>
+                      <a:pPr algn="l">
+                        <a:defRPr sz="800"/>
+                      </a:pPr>
                       <a:r>
                         <a:rPr lang="en-US" sz="1600" b="0" dirty="0">
                           <a:solidFill>
@@ -8382,14 +7995,16 @@
                       </a:r>
                     </a:p>
                   </a:txBody>
-                  <a:tcPr marL="121920" marR="121920" marT="76200" marB="76200" anchor="ctr"/>
+                  <a:tcPr marL="45720" marR="45720" marT="27432" marB="27432" anchor="ctr"/>
                 </a:tc>
                 <a:tc>
                   <a:txBody>
                     <a:bodyPr/>
                     <a:lstStyle/>
                     <a:p>
-                      <a:pPr algn="l"/>
+                      <a:pPr algn="l">
+                        <a:defRPr sz="800"/>
+                      </a:pPr>
                       <a:r>
                         <a:rPr lang="en-US" sz="1600" b="0">
                           <a:solidFill>
@@ -8406,14 +8021,16 @@
                       </a:r>
                     </a:p>
                   </a:txBody>
-                  <a:tcPr marL="121920" marR="121920" marT="76200" marB="76200" anchor="ctr"/>
+                  <a:tcPr marL="45720" marR="45720" marT="27432" marB="27432" anchor="ctr"/>
                 </a:tc>
                 <a:tc>
                   <a:txBody>
                     <a:bodyPr/>
                     <a:lstStyle/>
                     <a:p>
-                      <a:pPr algn="l"/>
+                      <a:pPr algn="l">
+                        <a:defRPr sz="800"/>
+                      </a:pPr>
                       <a:r>
                         <a:rPr lang="en-US" sz="1600" b="0">
                           <a:solidFill>
@@ -8430,14 +8047,16 @@
                       </a:r>
                     </a:p>
                   </a:txBody>
-                  <a:tcPr marL="121920" marR="121920" marT="76200" marB="76200" anchor="ctr"/>
+                  <a:tcPr marL="45720" marR="45720" marT="27432" marB="27432" anchor="ctr"/>
                 </a:tc>
                 <a:tc>
                   <a:txBody>
                     <a:bodyPr/>
                     <a:lstStyle/>
                     <a:p>
-                      <a:pPr algn="l"/>
+                      <a:pPr algn="l">
+                        <a:defRPr sz="800"/>
+                      </a:pPr>
                       <a:r>
                         <a:rPr lang="en-US" sz="1600" b="0" dirty="0">
                           <a:solidFill>
@@ -8454,7 +8073,7 @@
                       </a:r>
                     </a:p>
                   </a:txBody>
-                  <a:tcPr marL="121920" marR="121920" marT="76200" marB="76200" anchor="ctr"/>
+                  <a:tcPr marL="45720" marR="45720" marT="27432" marB="27432" anchor="ctr"/>
                 </a:tc>
                 <a:extLst>
                   <a:ext uri="{0D108BD9-81ED-4DB2-BD59-A6C34878D82A}">
@@ -8468,7 +8087,9 @@
                     <a:bodyPr/>
                     <a:lstStyle/>
                     <a:p>
-                      <a:pPr algn="l"/>
+                      <a:pPr algn="l">
+                        <a:defRPr sz="800"/>
+                      </a:pPr>
                       <a:r>
                         <a:rPr lang="en-GH" sz="1600" b="0" dirty="0">
                           <a:solidFill>
@@ -8538,14 +8159,16 @@
                       </a:endParaRPr>
                     </a:p>
                   </a:txBody>
-                  <a:tcPr marL="121920" marR="121920" marT="76200" marB="76200" anchor="ctr"/>
+                  <a:tcPr marL="45720" marR="45720" marT="27432" marB="27432" anchor="ctr"/>
                 </a:tc>
                 <a:tc>
                   <a:txBody>
                     <a:bodyPr/>
                     <a:lstStyle/>
                     <a:p>
-                      <a:pPr algn="l"/>
+                      <a:pPr algn="l">
+                        <a:defRPr sz="800"/>
+                      </a:pPr>
                       <a:r>
                         <a:rPr lang="en-US" sz="1600" b="0" dirty="0" err="1">
                           <a:solidFill>
@@ -8587,14 +8210,16 @@
                       </a:endParaRPr>
                     </a:p>
                   </a:txBody>
-                  <a:tcPr marL="121920" marR="121920" marT="76200" marB="76200" anchor="ctr"/>
+                  <a:tcPr marL="45720" marR="45720" marT="27432" marB="27432" anchor="ctr"/>
                 </a:tc>
                 <a:tc>
                   <a:txBody>
                     <a:bodyPr/>
                     <a:lstStyle/>
                     <a:p>
-                      <a:pPr algn="l"/>
+                      <a:pPr algn="l">
+                        <a:defRPr sz="800"/>
+                      </a:pPr>
                       <a:r>
                         <a:rPr lang="en-US" sz="1600" b="0" i="0" dirty="0">
                           <a:latin typeface="Gill Sans MT" panose="020B0502020104020203" pitchFamily="34" charset="0"/>
@@ -8614,26 +8239,31 @@
                       </a:endParaRPr>
                     </a:p>
                   </a:txBody>
-                  <a:tcPr marL="121920" marR="121920" marT="76200" marB="76200" anchor="ctr"/>
+                  <a:tcPr marL="45720" marR="45720" marT="27432" marB="27432" anchor="ctr"/>
                 </a:tc>
                 <a:tc>
                   <a:txBody>
                     <a:bodyPr/>
                     <a:lstStyle/>
                     <a:p>
+                      <a:pPr>
+                        <a:defRPr sz="800"/>
+                      </a:pPr>
                       <a:r>
                         <a:t>Predict human intention in real time using a single RGB-D camera.</a:t>
                       </a:r>
                     </a:p>
                   </a:txBody>
-                  <a:tcPr marL="121920" marR="121920" marT="76200" marB="76200" anchor="ctr"/>
+                  <a:tcPr marL="45720" marR="45720" marT="27432" marB="27432" anchor="ctr"/>
                 </a:tc>
                 <a:tc>
                   <a:txBody>
                     <a:bodyPr/>
                     <a:lstStyle/>
                     <a:p>
-                      <a:pPr algn="l"/>
+                      <a:pPr algn="l">
+                        <a:defRPr sz="800"/>
+                      </a:pPr>
                       <a:r>
                         <a:rPr lang="en-US" sz="1600" b="0" dirty="0" err="1">
                           <a:latin typeface="Gill Sans MT" panose="020B0502020104020203" pitchFamily="34" charset="0"/>
@@ -8659,19 +8289,22 @@
                       </a:endParaRPr>
                     </a:p>
                   </a:txBody>
-                  <a:tcPr marL="121920" marR="121920" marT="76200" marB="76200" anchor="ctr"/>
+                  <a:tcPr marL="45720" marR="45720" marT="27432" marB="27432" anchor="ctr"/>
                 </a:tc>
                 <a:tc>
                   <a:txBody>
                     <a:bodyPr/>
                     <a:lstStyle/>
                     <a:p>
+                      <a:pPr>
+                        <a:defRPr sz="800"/>
+                      </a:pPr>
                       <a:r>
-                        <a:t>Stationary UR3 manipulator arm without mobile base navigation or explicit touchless gesture command channel.</a:t>
+                        <a:t>Stationary UR3 arm without mobile base navigation or explicit gesture command channel.</a:t>
                       </a:r>
                     </a:p>
                   </a:txBody>
-                  <a:tcPr marL="121920" marR="121920" marT="76200" marB="76200" anchor="ctr"/>
+                  <a:tcPr marL="45720" marR="45720" marT="27432" marB="27432" anchor="ctr"/>
                 </a:tc>
                 <a:extLst>
                   <a:ext uri="{0D108BD9-81ED-4DB2-BD59-A6C34878D82A}">
@@ -8685,7 +8318,9 @@
                     <a:bodyPr/>
                     <a:lstStyle/>
                     <a:p>
-                      <a:pPr algn="l"/>
+                      <a:pPr algn="l">
+                        <a:defRPr sz="800"/>
+                      </a:pPr>
                       <a:r>
                         <a:rPr lang="en-GH" sz="1600" b="0" dirty="0">
                           <a:solidFill>
@@ -8730,26 +8365,31 @@
                       </a:r>
                     </a:p>
                   </a:txBody>
-                  <a:tcPr marL="121920" marR="121920" marT="76200" marB="76200" anchor="ctr"/>
+                  <a:tcPr marL="45720" marR="45720" marT="27432" marB="27432" anchor="ctr"/>
                 </a:tc>
                 <a:tc>
                   <a:txBody>
                     <a:bodyPr/>
                     <a:lstStyle/>
                     <a:p>
+                      <a:pPr>
+                        <a:defRPr sz="800"/>
+                      </a:pPr>
                       <a:r>
                         <a:t>Mahmud et al.</a:t>
                       </a:r>
                     </a:p>
                   </a:txBody>
-                  <a:tcPr marL="121920" marR="121920" marT="76200" marB="76200" anchor="ctr"/>
+                  <a:tcPr marL="45720" marR="45720" marT="27432" marB="27432" anchor="ctr"/>
                 </a:tc>
                 <a:tc>
                   <a:txBody>
                     <a:bodyPr/>
                     <a:lstStyle/>
                     <a:p>
-                      <a:pPr algn="l"/>
+                      <a:pPr algn="l">
+                        <a:defRPr sz="800"/>
+                      </a:pPr>
                       <a:r>
                         <a:rPr lang="en-US" sz="1600" b="0" dirty="0">
                           <a:latin typeface="Gill Sans MT" panose="020B0502020104020203" pitchFamily="34" charset="0"/>
@@ -8769,14 +8409,16 @@
                       </a:endParaRPr>
                     </a:p>
                   </a:txBody>
-                  <a:tcPr marL="121920" marR="121920" marT="76200" marB="76200" anchor="ctr"/>
+                  <a:tcPr marL="45720" marR="45720" marT="27432" marB="27432" anchor="ctr"/>
                 </a:tc>
                 <a:tc>
                   <a:txBody>
                     <a:bodyPr/>
                     <a:lstStyle/>
                     <a:p>
-                      <a:pPr algn="l"/>
+                      <a:pPr algn="l">
+                        <a:defRPr sz="800"/>
+                      </a:pPr>
                       <a:r>
                         <a:rPr lang="en-US" sz="1600" b="0" dirty="0">
                           <a:latin typeface="Gill Sans MT" panose="020B0502020104020203" pitchFamily="34" charset="0"/>
@@ -8796,14 +8438,16 @@
                       </a:endParaRPr>
                     </a:p>
                   </a:txBody>
-                  <a:tcPr marL="121920" marR="121920" marT="76200" marB="76200" anchor="ctr"/>
+                  <a:tcPr marL="45720" marR="45720" marT="27432" marB="27432" anchor="ctr"/>
                 </a:tc>
                 <a:tc>
                   <a:txBody>
                     <a:bodyPr/>
                     <a:lstStyle/>
                     <a:p>
-                      <a:pPr algn="l"/>
+                      <a:pPr algn="l">
+                        <a:defRPr sz="800"/>
+                      </a:pPr>
                       <a:r>
                         <a:rPr lang="en-US" sz="1600" b="0" dirty="0">
                           <a:latin typeface="Gill Sans MT" panose="020B0502020104020203" pitchFamily="34" charset="0"/>
@@ -8823,19 +8467,22 @@
                       </a:endParaRPr>
                     </a:p>
                   </a:txBody>
-                  <a:tcPr marL="121920" marR="121920" marT="76200" marB="76200" anchor="ctr"/>
+                  <a:tcPr marL="45720" marR="45720" marT="27432" marB="27432" anchor="ctr"/>
                 </a:tc>
                 <a:tc>
                   <a:txBody>
                     <a:bodyPr/>
                     <a:lstStyle/>
                     <a:p>
+                      <a:pPr>
+                        <a:defRPr sz="800"/>
+                      </a:pPr>
                       <a:r>
-                        <a:t>Restricted to proprietary high-power Kinect sensor; navigation evaluated only in simulation without physical latency or wheel slip.</a:t>
+                        <a:t>Restricted to proprietary Kinect sensor; navigation evaluated only in simulation without physical latency or wheel slip.</a:t>
                       </a:r>
                     </a:p>
                   </a:txBody>
-                  <a:tcPr marL="121920" marR="121920" marT="76200" marB="76200" anchor="ctr"/>
+                  <a:tcPr marL="45720" marR="45720" marT="27432" marB="27432" anchor="ctr"/>
                 </a:tc>
                 <a:extLst>
                   <a:ext uri="{0D108BD9-81ED-4DB2-BD59-A6C34878D82A}">
@@ -8849,7 +8496,9 @@
                     <a:bodyPr/>
                     <a:lstStyle/>
                     <a:p>
-                      <a:pPr algn="l"/>
+                      <a:pPr algn="l">
+                        <a:defRPr sz="800"/>
+                      </a:pPr>
                       <a:r>
                         <a:rPr lang="en-GH" sz="1600" b="0" dirty="0">
                           <a:solidFill>
@@ -8885,26 +8534,31 @@
                       </a:r>
                     </a:p>
                   </a:txBody>
-                  <a:tcPr marL="121920" marR="121920" marT="76200" marB="76200" anchor="ctr"/>
+                  <a:tcPr marL="45720" marR="45720" marT="27432" marB="27432" anchor="ctr"/>
                 </a:tc>
                 <a:tc>
                   <a:txBody>
                     <a:bodyPr/>
                     <a:lstStyle/>
                     <a:p>
+                      <a:pPr>
+                        <a:defRPr sz="800"/>
+                      </a:pPr>
                       <a:r>
                         <a:t>Yang et al. / Li et al.</a:t>
                       </a:r>
                     </a:p>
                   </a:txBody>
-                  <a:tcPr marL="121920" marR="121920" marT="76200" marB="76200" anchor="ctr"/>
+                  <a:tcPr marL="45720" marR="45720" marT="27432" marB="27432" anchor="ctr"/>
                 </a:tc>
                 <a:tc>
                   <a:txBody>
                     <a:bodyPr/>
                     <a:lstStyle/>
                     <a:p>
-                      <a:pPr algn="l"/>
+                      <a:pPr algn="l">
+                        <a:defRPr sz="800"/>
+                      </a:pPr>
                       <a:r>
                         <a:rPr lang="en-US" sz="1600" b="0" dirty="0">
                           <a:latin typeface="Gill Sans MT" panose="020B0502020104020203" pitchFamily="34" charset="0"/>
@@ -8921,14 +8575,16 @@
                       </a:endParaRPr>
                     </a:p>
                   </a:txBody>
-                  <a:tcPr marL="121920" marR="121920" marT="76200" marB="76200" anchor="ctr"/>
+                  <a:tcPr marL="45720" marR="45720" marT="27432" marB="27432" anchor="ctr"/>
                 </a:tc>
                 <a:tc>
                   <a:txBody>
                     <a:bodyPr/>
                     <a:lstStyle/>
                     <a:p>
-                      <a:pPr algn="l"/>
+                      <a:pPr algn="l">
+                        <a:defRPr sz="800"/>
+                      </a:pPr>
                       <a:r>
                         <a:rPr lang="en-US" sz="1600" b="0" dirty="0">
                           <a:latin typeface="Gill Sans MT" panose="020B0502020104020203" pitchFamily="34" charset="0"/>
@@ -8945,14 +8601,16 @@
                       </a:endParaRPr>
                     </a:p>
                   </a:txBody>
-                  <a:tcPr marL="121920" marR="121920" marT="76200" marB="76200" anchor="ctr"/>
+                  <a:tcPr marL="45720" marR="45720" marT="27432" marB="27432" anchor="ctr"/>
                 </a:tc>
                 <a:tc>
                   <a:txBody>
                     <a:bodyPr/>
                     <a:lstStyle/>
                     <a:p>
-                      <a:pPr algn="l"/>
+                      <a:pPr algn="l">
+                        <a:defRPr sz="800"/>
+                      </a:pPr>
                       <a:r>
                         <a:rPr lang="en-US" sz="1600" b="0" dirty="0">
                           <a:latin typeface="Gill Sans MT" panose="020B0502020104020203" pitchFamily="34" charset="0"/>
@@ -8981,19 +8639,22 @@
                       </a:endParaRPr>
                     </a:p>
                   </a:txBody>
-                  <a:tcPr marL="121920" marR="121920" marT="76200" marB="76200" anchor="ctr"/>
+                  <a:tcPr marL="45720" marR="45720" marT="27432" marB="27432" anchor="ctr"/>
                 </a:tc>
                 <a:tc>
                   <a:txBody>
                     <a:bodyPr/>
                     <a:lstStyle/>
                     <a:p>
+                      <a:pPr>
+                        <a:defRPr sz="800"/>
+                      </a:pPr>
                       <a:r>
-                        <a:t>Tested in simulation (Isaac Sim) for obstacle yielding; lacks touchless human supervisory gesture directives.</a:t>
+                        <a:t>Simulation only (Isaac Sim); predicts obstacle clearance but lacks touchless human supervisory control.</a:t>
                       </a:r>
                     </a:p>
                   </a:txBody>
-                  <a:tcPr marL="121920" marR="121920" marT="76200" marB="76200" anchor="ctr"/>
+                  <a:tcPr marL="45720" marR="45720" marT="27432" marB="27432" anchor="ctr"/>
                 </a:tc>
                 <a:extLst>
                   <a:ext uri="{0D108BD9-81ED-4DB2-BD59-A6C34878D82A}">
@@ -9050,829 +8711,39 @@
           <a:bodyPr/>
           <a:lstStyle/>
           <a:p>
-            <a:pPr algn="ctr"/>
-            <a:r>
-              <a:rPr lang="en-US" b="1" u="sng" dirty="0">
-                <a:gradFill>
-                  <a:gsLst>
-                    <a:gs pos="0">
-                      <a:srgbClr val="E30000"/>
-                    </a:gs>
-                    <a:gs pos="100000">
-                      <a:srgbClr val="760303"/>
-                    </a:gs>
-                  </a:gsLst>
-                  <a:lin scaled="0"/>
-                </a:gradFill>
-                <a:latin typeface="Gill Sans MT" panose="020B0502020104020203" pitchFamily="34" charset="0"/>
-                <a:cs typeface="Times New Roman" panose="02020603050405020304" pitchFamily="18" charset="0"/>
-              </a:rPr>
-              <a:t>METHODOLOGY</a:t>
-            </a:r>
-            <a:endParaRPr lang="en-US" b="1" dirty="0">
-              <a:solidFill>
-                <a:srgbClr val="C00000"/>
-              </a:solidFill>
-            </a:endParaRPr>
+            <a:pPr>
+              <a:defRPr sz="2200"/>
+            </a:pPr>
+            <a:r>
+              <a:t>SYSTEM DESIGN &amp; ENGINEERING METHODOLOGY</a:t>
+            </a:r>
           </a:p>
         </p:txBody>
       </p:sp>
-      <p:sp>
-        <p:nvSpPr>
-          <p:cNvPr id="5" name="Rectangle 2"/>
-          <p:cNvSpPr>
-            <a:spLocks noGrp="1" noChangeArrowheads="1"/>
-          </p:cNvSpPr>
-          <p:nvPr>
-            <p:ph idx="1"/>
-          </p:nvPr>
-        </p:nvSpPr>
-        <p:spPr bwMode="auto">
+      <p:pic>
+        <p:nvPicPr>
+          <p:cNvPr id="3" name="Picture 2" descr="fig_accepted_methodology.png"/>
+          <p:cNvPicPr>
+            <a:picLocks noChangeAspect="1"/>
+          </p:cNvPicPr>
+          <p:nvPr/>
+        </p:nvPicPr>
+        <p:blipFill>
+          <a:blip r:embed="rId2"/>
+          <a:stretch>
+            <a:fillRect/>
+          </a:stretch>
+        </p:blipFill>
+        <p:spPr>
           <a:xfrm>
-            <a:off x="914400" y="2836595"/>
-            <a:ext cx="9987132" cy="1143070"/>
+            <a:off x="731520" y="1234440"/>
+            <a:ext cx="10725912" cy="5166360"/>
           </a:xfrm>
           <a:prstGeom prst="rect">
             <a:avLst/>
           </a:prstGeom>
-          <a:noFill/>
-          <a:ln>
-            <a:noFill/>
-          </a:ln>
-          <a:effectLst/>
-          <a:extLst>
-            <a:ext uri="{909E8E84-426E-40DD-AFC4-6F175D3DCCD1}">
-              <a14:hiddenFill xmlns:a14="http://schemas.microsoft.com/office/drawing/2010/main">
-                <a:solidFill>
-                  <a:schemeClr val="accent1"/>
-                </a:solidFill>
-              </a14:hiddenFill>
-            </a:ext>
-            <a:ext uri="{91240B29-F687-4F45-9708-019B960494DF}">
-              <a14:hiddenLine xmlns:a14="http://schemas.microsoft.com/office/drawing/2010/main" w="9525">
-                <a:solidFill>
-                  <a:schemeClr val="tx1"/>
-                </a:solidFill>
-                <a:miter lim="800000"/>
-                <a:headEnd/>
-                <a:tailEnd/>
-              </a14:hiddenLine>
-            </a:ext>
-            <a:ext uri="{AF507438-7753-43E0-B8FC-AC1667EBCBE1}">
-              <a14:hiddenEffects xmlns:a14="http://schemas.microsoft.com/office/drawing/2010/main">
-                <a:effectLst>
-                  <a:outerShdw dist="35921" dir="2700000" algn="ctr" rotWithShape="0">
-                    <a:schemeClr val="bg2"/>
-                  </a:outerShdw>
-                </a:effectLst>
-              </a14:hiddenEffects>
-            </a:ext>
-          </a:extLst>
         </p:spPr>
-        <p:txBody>
-          <a:bodyPr vert="horz" wrap="square" lIns="91440" tIns="45720" rIns="91440" bIns="45720" numCol="1" anchor="ctr" anchorCtr="0" compatLnSpc="1">
-            <a:prstTxWarp prst="textNoShape">
-              <a:avLst/>
-            </a:prstTxWarp>
-            <a:spAutoFit/>
-          </a:bodyPr>
-          <a:lstStyle/>
-          <a:p>
-            <a:pPr marL="0" marR="0" lvl="0" indent="0" algn="l" defTabSz="914400" rtl="0" eaLnBrk="0" fontAlgn="base" latinLnBrk="0" hangingPunct="0">
-              <a:lnSpc>
-                <a:spcPct val="150000"/>
-              </a:lnSpc>
-              <a:spcBef>
-                <a:spcPct val="0"/>
-              </a:spcBef>
-              <a:spcAft>
-                <a:spcPct val="0"/>
-              </a:spcAft>
-              <a:buClrTx/>
-              <a:buSzTx/>
-              <a:buNone/>
-              <a:tabLst/>
-            </a:pPr>
-            <a:endParaRPr kumimoji="0" lang="en-US" altLang="en-US" sz="2400" i="0" u="none" strike="noStrike" cap="none" normalizeH="0" baseline="0" dirty="0">
-              <a:ln>
-                <a:noFill/>
-              </a:ln>
-              <a:effectLst/>
-            </a:endParaRPr>
-          </a:p>
-          <a:p>
-            <a:pPr marL="0" marR="0" lvl="0" indent="0" algn="l" defTabSz="914400" rtl="0" eaLnBrk="0" fontAlgn="base" latinLnBrk="0" hangingPunct="0">
-              <a:lnSpc>
-                <a:spcPct val="150000"/>
-              </a:lnSpc>
-              <a:spcBef>
-                <a:spcPct val="0"/>
-              </a:spcBef>
-              <a:spcAft>
-                <a:spcPct val="0"/>
-              </a:spcAft>
-              <a:buClrTx/>
-              <a:buSzTx/>
-              <a:buFontTx/>
-              <a:buChar char="•"/>
-              <a:tabLst/>
-            </a:pPr>
-            <a:endParaRPr kumimoji="0" lang="en-US" altLang="en-US" sz="2400" i="0" u="none" strike="noStrike" cap="none" normalizeH="0" baseline="0" dirty="0">
-              <a:ln>
-                <a:noFill/>
-              </a:ln>
-              <a:effectLst/>
-            </a:endParaRPr>
-          </a:p>
-        </p:txBody>
-      </p:sp>
-      <p:graphicFrame>
-        <p:nvGraphicFramePr>
-          <p:cNvPr id="3" name="Table 2"/>
-          <p:cNvGraphicFramePr>
-            <a:graphicFrameLocks noGrp="1"/>
-          </p:cNvGraphicFramePr>
-          <p:nvPr>
-            <p:extLst>
-              <p:ext uri="{D42A27DB-BD31-4B8C-83A1-F6EECF244321}">
-                <p14:modId xmlns:p14="http://schemas.microsoft.com/office/powerpoint/2010/main" val="4031862827"/>
-              </p:ext>
-            </p:extLst>
-          </p:nvPr>
-        </p:nvGraphicFramePr>
-        <p:xfrm>
-          <a:off x="2032000" y="1690688"/>
-          <a:ext cx="8128000" cy="365760"/>
-        </p:xfrm>
-        <a:graphic>
-          <a:graphicData uri="http://schemas.openxmlformats.org/drawingml/2006/table">
-            <a:tbl>
-              <a:tblPr firstRow="1" bandRow="1">
-                <a:tableStyleId>{5C22544A-7EE6-4342-B048-85BDC9FD1C3A}</a:tableStyleId>
-              </a:tblPr>
-              <a:tblGrid>
-                <a:gridCol w="8128000">
-                  <a:extLst>
-                    <a:ext uri="{9D8B030D-6E8A-4147-A177-3AD203B41FA5}">
-                      <a16:colId xmlns:a16="http://schemas.microsoft.com/office/drawing/2014/main" val="3890807610"/>
-                    </a:ext>
-                  </a:extLst>
-                </a:gridCol>
-              </a:tblGrid>
-              <a:tr h="260885">
-                <a:tc>
-                  <a:txBody>
-                    <a:bodyPr/>
-                    <a:lstStyle/>
-                    <a:p>
-                      <a:r>
-                        <a:rPr lang="en-US" dirty="0">
-                          <a:latin typeface="Gill Sans MT" panose="020B0502020104020203" pitchFamily="34" charset="0"/>
-                        </a:rPr>
-                        <a:t>System Architecture</a:t>
-                      </a:r>
-                    </a:p>
-                  </a:txBody>
-                  <a:tcPr/>
-                </a:tc>
-                <a:extLst>
-                  <a:ext uri="{0D108BD9-81ED-4DB2-BD59-A6C34878D82A}">
-                    <a16:rowId xmlns:a16="http://schemas.microsoft.com/office/drawing/2014/main" val="4233928430"/>
-                  </a:ext>
-                </a:extLst>
-              </a:tr>
-            </a:tbl>
-          </a:graphicData>
-        </a:graphic>
-      </p:graphicFrame>
-      <p:sp>
-        <p:nvSpPr>
-          <p:cNvPr id="4" name="Down Arrow 3"/>
-          <p:cNvSpPr/>
-          <p:nvPr/>
-        </p:nvSpPr>
-        <p:spPr>
-          <a:xfrm>
-            <a:off x="5834358" y="2078221"/>
-            <a:ext cx="261642" cy="244193"/>
-          </a:xfrm>
-          <a:prstGeom prst="downArrow">
-            <a:avLst/>
-          </a:prstGeom>
-        </p:spPr>
-        <p:style>
-          <a:lnRef idx="2">
-            <a:schemeClr val="accent1">
-              <a:shade val="50000"/>
-            </a:schemeClr>
-          </a:lnRef>
-          <a:fillRef idx="1">
-            <a:schemeClr val="accent1"/>
-          </a:fillRef>
-          <a:effectRef idx="0">
-            <a:schemeClr val="accent1"/>
-          </a:effectRef>
-          <a:fontRef idx="minor">
-            <a:schemeClr val="lt1"/>
-          </a:fontRef>
-        </p:style>
-        <p:txBody>
-          <a:bodyPr rtlCol="0" anchor="ctr"/>
-          <a:lstStyle/>
-          <a:p>
-            <a:pPr algn="ctr"/>
-            <a:endParaRPr lang="en-US"/>
-          </a:p>
-        </p:txBody>
-      </p:sp>
-      <p:graphicFrame>
-        <p:nvGraphicFramePr>
-          <p:cNvPr id="6" name="Table 5"/>
-          <p:cNvGraphicFramePr>
-            <a:graphicFrameLocks noGrp="1"/>
-          </p:cNvGraphicFramePr>
-          <p:nvPr>
-            <p:extLst>
-              <p:ext uri="{D42A27DB-BD31-4B8C-83A1-F6EECF244321}">
-                <p14:modId xmlns:p14="http://schemas.microsoft.com/office/powerpoint/2010/main" val="2223812988"/>
-              </p:ext>
-            </p:extLst>
-          </p:nvPr>
-        </p:nvGraphicFramePr>
-        <p:xfrm>
-          <a:off x="2032000" y="2339107"/>
-          <a:ext cx="8128000" cy="370840"/>
-        </p:xfrm>
-        <a:graphic>
-          <a:graphicData uri="http://schemas.openxmlformats.org/drawingml/2006/table">
-            <a:tbl>
-              <a:tblPr firstRow="1" bandRow="1">
-                <a:tableStyleId>{5C22544A-7EE6-4342-B048-85BDC9FD1C3A}</a:tableStyleId>
-              </a:tblPr>
-              <a:tblGrid>
-                <a:gridCol w="8128000">
-                  <a:extLst>
-                    <a:ext uri="{9D8B030D-6E8A-4147-A177-3AD203B41FA5}">
-                      <a16:colId xmlns:a16="http://schemas.microsoft.com/office/drawing/2014/main" val="3890807610"/>
-                    </a:ext>
-                  </a:extLst>
-                </a:gridCol>
-              </a:tblGrid>
-              <a:tr h="370840">
-                <a:tc>
-                  <a:txBody>
-                    <a:bodyPr/>
-                    <a:lstStyle/>
-                    <a:p>
-                      <a:r>
-                        <a:rPr lang="en-US" dirty="0">
-                          <a:latin typeface="Gill Sans MT" panose="020B0502020104020203" pitchFamily="34" charset="0"/>
-                        </a:rPr>
-                        <a:t>Hardware &amp; Software Setup</a:t>
-                      </a:r>
-                    </a:p>
-                  </a:txBody>
-                  <a:tcPr/>
-                </a:tc>
-                <a:extLst>
-                  <a:ext uri="{0D108BD9-81ED-4DB2-BD59-A6C34878D82A}">
-                    <a16:rowId xmlns:a16="http://schemas.microsoft.com/office/drawing/2014/main" val="4233928430"/>
-                  </a:ext>
-                </a:extLst>
-              </a:tr>
-            </a:tbl>
-          </a:graphicData>
-        </a:graphic>
-      </p:graphicFrame>
-      <p:graphicFrame>
-        <p:nvGraphicFramePr>
-          <p:cNvPr id="8" name="Table 7"/>
-          <p:cNvGraphicFramePr>
-            <a:graphicFrameLocks noGrp="1"/>
-          </p:cNvGraphicFramePr>
-          <p:nvPr>
-            <p:extLst>
-              <p:ext uri="{D42A27DB-BD31-4B8C-83A1-F6EECF244321}">
-                <p14:modId xmlns:p14="http://schemas.microsoft.com/office/powerpoint/2010/main" val="1977572646"/>
-              </p:ext>
-            </p:extLst>
-          </p:nvPr>
-        </p:nvGraphicFramePr>
-        <p:xfrm>
-          <a:off x="2032000" y="3033845"/>
-          <a:ext cx="8128000" cy="370840"/>
-        </p:xfrm>
-        <a:graphic>
-          <a:graphicData uri="http://schemas.openxmlformats.org/drawingml/2006/table">
-            <a:tbl>
-              <a:tblPr firstRow="1" bandRow="1">
-                <a:tableStyleId>{5C22544A-7EE6-4342-B048-85BDC9FD1C3A}</a:tableStyleId>
-              </a:tblPr>
-              <a:tblGrid>
-                <a:gridCol w="8128000">
-                  <a:extLst>
-                    <a:ext uri="{9D8B030D-6E8A-4147-A177-3AD203B41FA5}">
-                      <a16:colId xmlns:a16="http://schemas.microsoft.com/office/drawing/2014/main" val="3890807610"/>
-                    </a:ext>
-                  </a:extLst>
-                </a:gridCol>
-              </a:tblGrid>
-              <a:tr h="370840">
-                <a:tc>
-                  <a:txBody>
-                    <a:bodyPr/>
-                    <a:lstStyle/>
-                    <a:p>
-                      <a:pPr marL="0" marR="0" lvl="0" indent="0" algn="l" defTabSz="914400" rtl="0" eaLnBrk="1" fontAlgn="auto" latinLnBrk="0" hangingPunct="1">
-                        <a:lnSpc>
-                          <a:spcPct val="100000"/>
-                        </a:lnSpc>
-                        <a:spcBef>
-                          <a:spcPts val="0"/>
-                        </a:spcBef>
-                        <a:spcAft>
-                          <a:spcPts val="0"/>
-                        </a:spcAft>
-                        <a:buClrTx/>
-                        <a:buSzTx/>
-                        <a:buFontTx/>
-                        <a:buNone/>
-                        <a:tabLst/>
-                        <a:defRPr/>
-                      </a:pPr>
-                      <a:r>
-                        <a:rPr lang="en-US" dirty="0">
-                          <a:latin typeface="Gill Sans MT" panose="020B0502020104020203" pitchFamily="34" charset="0"/>
-                        </a:rPr>
-                        <a:t>Dataset Collection and Preprocessing</a:t>
-                      </a:r>
-                    </a:p>
-                  </a:txBody>
-                  <a:tcPr/>
-                </a:tc>
-                <a:extLst>
-                  <a:ext uri="{0D108BD9-81ED-4DB2-BD59-A6C34878D82A}">
-                    <a16:rowId xmlns:a16="http://schemas.microsoft.com/office/drawing/2014/main" val="4233928430"/>
-                  </a:ext>
-                </a:extLst>
-              </a:tr>
-            </a:tbl>
-          </a:graphicData>
-        </a:graphic>
-      </p:graphicFrame>
-      <p:sp>
-        <p:nvSpPr>
-          <p:cNvPr id="10" name="Down Arrow 9"/>
-          <p:cNvSpPr/>
-          <p:nvPr/>
-        </p:nvSpPr>
-        <p:spPr>
-          <a:xfrm>
-            <a:off x="5834358" y="2756330"/>
-            <a:ext cx="261642" cy="244193"/>
-          </a:xfrm>
-          <a:prstGeom prst="downArrow">
-            <a:avLst/>
-          </a:prstGeom>
-        </p:spPr>
-        <p:style>
-          <a:lnRef idx="2">
-            <a:schemeClr val="accent1">
-              <a:shade val="50000"/>
-            </a:schemeClr>
-          </a:lnRef>
-          <a:fillRef idx="1">
-            <a:schemeClr val="accent1"/>
-          </a:fillRef>
-          <a:effectRef idx="0">
-            <a:schemeClr val="accent1"/>
-          </a:effectRef>
-          <a:fontRef idx="minor">
-            <a:schemeClr val="lt1"/>
-          </a:fontRef>
-        </p:style>
-        <p:txBody>
-          <a:bodyPr rtlCol="0" anchor="ctr"/>
-          <a:lstStyle/>
-          <a:p>
-            <a:pPr algn="ctr"/>
-            <a:endParaRPr lang="en-US"/>
-          </a:p>
-        </p:txBody>
-      </p:sp>
-      <p:sp>
-        <p:nvSpPr>
-          <p:cNvPr id="11" name="Down Arrow 10"/>
-          <p:cNvSpPr/>
-          <p:nvPr/>
-        </p:nvSpPr>
-        <p:spPr>
-          <a:xfrm>
-            <a:off x="5834358" y="3438007"/>
-            <a:ext cx="261642" cy="244193"/>
-          </a:xfrm>
-          <a:prstGeom prst="downArrow">
-            <a:avLst/>
-          </a:prstGeom>
-        </p:spPr>
-        <p:style>
-          <a:lnRef idx="2">
-            <a:schemeClr val="accent1">
-              <a:shade val="50000"/>
-            </a:schemeClr>
-          </a:lnRef>
-          <a:fillRef idx="1">
-            <a:schemeClr val="accent1"/>
-          </a:fillRef>
-          <a:effectRef idx="0">
-            <a:schemeClr val="accent1"/>
-          </a:effectRef>
-          <a:fontRef idx="minor">
-            <a:schemeClr val="lt1"/>
-          </a:fontRef>
-        </p:style>
-        <p:txBody>
-          <a:bodyPr rtlCol="0" anchor="ctr"/>
-          <a:lstStyle/>
-          <a:p>
-            <a:pPr algn="ctr"/>
-            <a:endParaRPr lang="en-US"/>
-          </a:p>
-        </p:txBody>
-      </p:sp>
-      <p:graphicFrame>
-        <p:nvGraphicFramePr>
-          <p:cNvPr id="12" name="Table 11"/>
-          <p:cNvGraphicFramePr>
-            <a:graphicFrameLocks noGrp="1"/>
-          </p:cNvGraphicFramePr>
-          <p:nvPr>
-            <p:extLst>
-              <p:ext uri="{D42A27DB-BD31-4B8C-83A1-F6EECF244321}">
-                <p14:modId xmlns:p14="http://schemas.microsoft.com/office/powerpoint/2010/main" val="3871375454"/>
-              </p:ext>
-            </p:extLst>
-          </p:nvPr>
-        </p:nvGraphicFramePr>
-        <p:xfrm>
-          <a:off x="2032000" y="3670434"/>
-          <a:ext cx="8128000" cy="370840"/>
-        </p:xfrm>
-        <a:graphic>
-          <a:graphicData uri="http://schemas.openxmlformats.org/drawingml/2006/table">
-            <a:tbl>
-              <a:tblPr firstRow="1" bandRow="1">
-                <a:tableStyleId>{5C22544A-7EE6-4342-B048-85BDC9FD1C3A}</a:tableStyleId>
-              </a:tblPr>
-              <a:tblGrid>
-                <a:gridCol w="8128000">
-                  <a:extLst>
-                    <a:ext uri="{9D8B030D-6E8A-4147-A177-3AD203B41FA5}">
-                      <a16:colId xmlns:a16="http://schemas.microsoft.com/office/drawing/2014/main" val="3890807610"/>
-                    </a:ext>
-                  </a:extLst>
-                </a:gridCol>
-              </a:tblGrid>
-              <a:tr h="370840">
-                <a:tc>
-                  <a:txBody>
-                    <a:bodyPr/>
-                    <a:lstStyle/>
-                    <a:p>
-                      <a:pPr marL="0" marR="0" lvl="0" indent="0" algn="l" defTabSz="914400" rtl="0" eaLnBrk="1" fontAlgn="auto" latinLnBrk="0" hangingPunct="1">
-                        <a:lnSpc>
-                          <a:spcPct val="100000"/>
-                        </a:lnSpc>
-                        <a:spcBef>
-                          <a:spcPts val="0"/>
-                        </a:spcBef>
-                        <a:spcAft>
-                          <a:spcPts val="0"/>
-                        </a:spcAft>
-                        <a:buClrTx/>
-                        <a:buSzTx/>
-                        <a:buFontTx/>
-                        <a:buNone/>
-                        <a:tabLst/>
-                        <a:defRPr/>
-                      </a:pPr>
-                      <a:r>
-                        <a:rPr lang="en-US" dirty="0">
-                          <a:latin typeface="Gill Sans MT" panose="020B0502020104020203" pitchFamily="34" charset="0"/>
-                        </a:rPr>
-                        <a:t>Gesture Recognition Pipeline</a:t>
-                      </a:r>
-                    </a:p>
-                  </a:txBody>
-                  <a:tcPr/>
-                </a:tc>
-                <a:extLst>
-                  <a:ext uri="{0D108BD9-81ED-4DB2-BD59-A6C34878D82A}">
-                    <a16:rowId xmlns:a16="http://schemas.microsoft.com/office/drawing/2014/main" val="4233928430"/>
-                  </a:ext>
-                </a:extLst>
-              </a:tr>
-            </a:tbl>
-          </a:graphicData>
-        </a:graphic>
-      </p:graphicFrame>
-      <p:sp>
-        <p:nvSpPr>
-          <p:cNvPr id="13" name="Down Arrow 12"/>
-          <p:cNvSpPr/>
-          <p:nvPr/>
-        </p:nvSpPr>
-        <p:spPr>
-          <a:xfrm>
-            <a:off x="5834358" y="4123317"/>
-            <a:ext cx="261642" cy="244193"/>
-          </a:xfrm>
-          <a:prstGeom prst="downArrow">
-            <a:avLst/>
-          </a:prstGeom>
-        </p:spPr>
-        <p:style>
-          <a:lnRef idx="2">
-            <a:schemeClr val="accent1">
-              <a:shade val="50000"/>
-            </a:schemeClr>
-          </a:lnRef>
-          <a:fillRef idx="1">
-            <a:schemeClr val="accent1"/>
-          </a:fillRef>
-          <a:effectRef idx="0">
-            <a:schemeClr val="accent1"/>
-          </a:effectRef>
-          <a:fontRef idx="minor">
-            <a:schemeClr val="lt1"/>
-          </a:fontRef>
-        </p:style>
-        <p:txBody>
-          <a:bodyPr rtlCol="0" anchor="ctr"/>
-          <a:lstStyle/>
-          <a:p>
-            <a:pPr algn="ctr"/>
-            <a:endParaRPr lang="en-US"/>
-          </a:p>
-        </p:txBody>
-      </p:sp>
-      <p:graphicFrame>
-        <p:nvGraphicFramePr>
-          <p:cNvPr id="14" name="Table 13"/>
-          <p:cNvGraphicFramePr>
-            <a:graphicFrameLocks noGrp="1"/>
-          </p:cNvGraphicFramePr>
-          <p:nvPr>
-            <p:extLst>
-              <p:ext uri="{D42A27DB-BD31-4B8C-83A1-F6EECF244321}">
-                <p14:modId xmlns:p14="http://schemas.microsoft.com/office/powerpoint/2010/main" val="1060008672"/>
-              </p:ext>
-            </p:extLst>
-          </p:nvPr>
-        </p:nvGraphicFramePr>
-        <p:xfrm>
-          <a:off x="2032000" y="4367510"/>
-          <a:ext cx="8128000" cy="370840"/>
-        </p:xfrm>
-        <a:graphic>
-          <a:graphicData uri="http://schemas.openxmlformats.org/drawingml/2006/table">
-            <a:tbl>
-              <a:tblPr firstRow="1" bandRow="1">
-                <a:tableStyleId>{5C22544A-7EE6-4342-B048-85BDC9FD1C3A}</a:tableStyleId>
-              </a:tblPr>
-              <a:tblGrid>
-                <a:gridCol w="8128000">
-                  <a:extLst>
-                    <a:ext uri="{9D8B030D-6E8A-4147-A177-3AD203B41FA5}">
-                      <a16:colId xmlns:a16="http://schemas.microsoft.com/office/drawing/2014/main" val="3890807610"/>
-                    </a:ext>
-                  </a:extLst>
-                </a:gridCol>
-              </a:tblGrid>
-              <a:tr h="370840">
-                <a:tc>
-                  <a:txBody>
-                    <a:bodyPr/>
-                    <a:lstStyle/>
-                    <a:p>
-                      <a:r>
-                        <a:rPr lang="en-US" dirty="0">
-                          <a:latin typeface="Gill Sans MT" panose="020B0502020104020203" pitchFamily="34" charset="0"/>
-                        </a:rPr>
-                        <a:t>Brain Node Decision Making</a:t>
-                      </a:r>
-                    </a:p>
-                  </a:txBody>
-                  <a:tcPr/>
-                </a:tc>
-                <a:extLst>
-                  <a:ext uri="{0D108BD9-81ED-4DB2-BD59-A6C34878D82A}">
-                    <a16:rowId xmlns:a16="http://schemas.microsoft.com/office/drawing/2014/main" val="4233928430"/>
-                  </a:ext>
-                </a:extLst>
-              </a:tr>
-            </a:tbl>
-          </a:graphicData>
-        </a:graphic>
-      </p:graphicFrame>
-      <p:sp>
-        <p:nvSpPr>
-          <p:cNvPr id="15" name="Down Arrow 14"/>
-          <p:cNvSpPr/>
-          <p:nvPr/>
-        </p:nvSpPr>
-        <p:spPr>
-          <a:xfrm>
-            <a:off x="5834358" y="4760437"/>
-            <a:ext cx="261642" cy="244193"/>
-          </a:xfrm>
-          <a:prstGeom prst="downArrow">
-            <a:avLst/>
-          </a:prstGeom>
-        </p:spPr>
-        <p:style>
-          <a:lnRef idx="2">
-            <a:schemeClr val="accent1">
-              <a:shade val="50000"/>
-            </a:schemeClr>
-          </a:lnRef>
-          <a:fillRef idx="1">
-            <a:schemeClr val="accent1"/>
-          </a:fillRef>
-          <a:effectRef idx="0">
-            <a:schemeClr val="accent1"/>
-          </a:effectRef>
-          <a:fontRef idx="minor">
-            <a:schemeClr val="lt1"/>
-          </a:fontRef>
-        </p:style>
-        <p:txBody>
-          <a:bodyPr rtlCol="0" anchor="ctr"/>
-          <a:lstStyle/>
-          <a:p>
-            <a:pPr algn="ctr"/>
-            <a:endParaRPr lang="en-US"/>
-          </a:p>
-        </p:txBody>
-      </p:sp>
-      <p:graphicFrame>
-        <p:nvGraphicFramePr>
-          <p:cNvPr id="16" name="Table 15"/>
-          <p:cNvGraphicFramePr>
-            <a:graphicFrameLocks noGrp="1"/>
-          </p:cNvGraphicFramePr>
-          <p:nvPr>
-            <p:extLst>
-              <p:ext uri="{D42A27DB-BD31-4B8C-83A1-F6EECF244321}">
-                <p14:modId xmlns:p14="http://schemas.microsoft.com/office/powerpoint/2010/main" val="2272024717"/>
-              </p:ext>
-            </p:extLst>
-          </p:nvPr>
-        </p:nvGraphicFramePr>
-        <p:xfrm>
-          <a:off x="2032000" y="5026717"/>
-          <a:ext cx="8128000" cy="370840"/>
-        </p:xfrm>
-        <a:graphic>
-          <a:graphicData uri="http://schemas.openxmlformats.org/drawingml/2006/table">
-            <a:tbl>
-              <a:tblPr firstRow="1" bandRow="1">
-                <a:tableStyleId>{5C22544A-7EE6-4342-B048-85BDC9FD1C3A}</a:tableStyleId>
-              </a:tblPr>
-              <a:tblGrid>
-                <a:gridCol w="8128000">
-                  <a:extLst>
-                    <a:ext uri="{9D8B030D-6E8A-4147-A177-3AD203B41FA5}">
-                      <a16:colId xmlns:a16="http://schemas.microsoft.com/office/drawing/2014/main" val="3890807610"/>
-                    </a:ext>
-                  </a:extLst>
-                </a:gridCol>
-              </a:tblGrid>
-              <a:tr h="370840">
-                <a:tc>
-                  <a:txBody>
-                    <a:bodyPr/>
-                    <a:lstStyle/>
-                    <a:p>
-                      <a:r>
-                        <a:rPr lang="en-US" dirty="0">
-                          <a:latin typeface="Gill Sans MT" panose="020B0502020104020203" pitchFamily="34" charset="0"/>
-                        </a:rPr>
-                        <a:t>ROS2 Integration</a:t>
-                      </a:r>
-                    </a:p>
-                  </a:txBody>
-                  <a:tcPr/>
-                </a:tc>
-                <a:extLst>
-                  <a:ext uri="{0D108BD9-81ED-4DB2-BD59-A6C34878D82A}">
-                    <a16:rowId xmlns:a16="http://schemas.microsoft.com/office/drawing/2014/main" val="4233928430"/>
-                  </a:ext>
-                </a:extLst>
-              </a:tr>
-            </a:tbl>
-          </a:graphicData>
-        </a:graphic>
-      </p:graphicFrame>
-      <p:sp>
-        <p:nvSpPr>
-          <p:cNvPr id="17" name="Down Arrow 16"/>
-          <p:cNvSpPr/>
-          <p:nvPr/>
-        </p:nvSpPr>
-        <p:spPr>
-          <a:xfrm>
-            <a:off x="5834358" y="5447672"/>
-            <a:ext cx="261642" cy="244193"/>
-          </a:xfrm>
-          <a:prstGeom prst="downArrow">
-            <a:avLst/>
-          </a:prstGeom>
-        </p:spPr>
-        <p:style>
-          <a:lnRef idx="2">
-            <a:schemeClr val="accent1">
-              <a:shade val="50000"/>
-            </a:schemeClr>
-          </a:lnRef>
-          <a:fillRef idx="1">
-            <a:schemeClr val="accent1"/>
-          </a:fillRef>
-          <a:effectRef idx="0">
-            <a:schemeClr val="accent1"/>
-          </a:effectRef>
-          <a:fontRef idx="minor">
-            <a:schemeClr val="lt1"/>
-          </a:fontRef>
-        </p:style>
-        <p:txBody>
-          <a:bodyPr rtlCol="0" anchor="ctr"/>
-          <a:lstStyle/>
-          <a:p>
-            <a:pPr algn="ctr"/>
-            <a:endParaRPr lang="en-US"/>
-          </a:p>
-        </p:txBody>
-      </p:sp>
-      <p:graphicFrame>
-        <p:nvGraphicFramePr>
-          <p:cNvPr id="18" name="Table 17"/>
-          <p:cNvGraphicFramePr>
-            <a:graphicFrameLocks noGrp="1"/>
-          </p:cNvGraphicFramePr>
-          <p:nvPr>
-            <p:extLst>
-              <p:ext uri="{D42A27DB-BD31-4B8C-83A1-F6EECF244321}">
-                <p14:modId xmlns:p14="http://schemas.microsoft.com/office/powerpoint/2010/main" val="623469389"/>
-              </p:ext>
-            </p:extLst>
-          </p:nvPr>
-        </p:nvGraphicFramePr>
-        <p:xfrm>
-          <a:off x="2032000" y="5741980"/>
-          <a:ext cx="8128000" cy="370840"/>
-        </p:xfrm>
-        <a:graphic>
-          <a:graphicData uri="http://schemas.openxmlformats.org/drawingml/2006/table">
-            <a:tbl>
-              <a:tblPr firstRow="1" bandRow="1">
-                <a:tableStyleId>{5C22544A-7EE6-4342-B048-85BDC9FD1C3A}</a:tableStyleId>
-              </a:tblPr>
-              <a:tblGrid>
-                <a:gridCol w="8128000">
-                  <a:extLst>
-                    <a:ext uri="{9D8B030D-6E8A-4147-A177-3AD203B41FA5}">
-                      <a16:colId xmlns:a16="http://schemas.microsoft.com/office/drawing/2014/main" val="3890807610"/>
-                    </a:ext>
-                  </a:extLst>
-                </a:gridCol>
-              </a:tblGrid>
-              <a:tr h="370840">
-                <a:tc>
-                  <a:txBody>
-                    <a:bodyPr/>
-                    <a:lstStyle/>
-                    <a:p>
-                      <a:r>
-                        <a:rPr lang="en-US" dirty="0">
-                          <a:latin typeface="Gill Sans MT" panose="020B0502020104020203" pitchFamily="34" charset="0"/>
-                        </a:rPr>
-                        <a:t>SLAM &amp; Navigation</a:t>
-                      </a:r>
-                    </a:p>
-                  </a:txBody>
-                  <a:tcPr/>
-                </a:tc>
-                <a:extLst>
-                  <a:ext uri="{0D108BD9-81ED-4DB2-BD59-A6C34878D82A}">
-                    <a16:rowId xmlns:a16="http://schemas.microsoft.com/office/drawing/2014/main" val="4233928430"/>
-                  </a:ext>
-                </a:extLst>
-              </a:tr>
-            </a:tbl>
-          </a:graphicData>
-        </a:graphic>
-      </p:graphicFrame>
+      </p:pic>
     </p:spTree>
     <p:extLst>
       <p:ext uri="{BB962C8B-B14F-4D97-AF65-F5344CB8AC3E}">
@@ -9981,6 +8852,9 @@
           </a:bodyPr>
           <a:lstStyle/>
           <a:p>
+            <a:pPr>
+              <a:defRPr sz="950"/>
+            </a:pPr>
             <a:r>
               <a:t>Figure 3: Hardware Architecture and Signal Distribution</a:t>
             </a:r>

</xml_diff>